<commit_message>
Updates W19 s9 DA analisis de cohortes
</commit_message>
<xml_diff>
--- a/07-herramientas-desarrollo/15-proyecto-github.pptx
+++ b/07-herramientas-desarrollo/15-proyecto-github.pptx
@@ -12,22 +12,21 @@
     <p:sldId id="260" r:id="rId7"/>
     <p:sldId id="261" r:id="rId8"/>
     <p:sldId id="262" r:id="rId9"/>
-    <p:sldId id="263" r:id="rId10"/>
   </p:sldIdLst>
   <p:sldSz cx="9144000" cy="5143500"/>
-  <p:notesSz cx="6858000" cy="9144000"/>
+  <p:notesSz cx="7772400" cy="10058400"/>
   <p:embeddedFontLst>
-    <p:embeddedFont>
-      <p:font typeface="Inter ExtraBold"/>
-    </p:embeddedFont>
     <p:embeddedFont>
       <p:font typeface="Inter Medium"/>
     </p:embeddedFont>
     <p:embeddedFont>
       <p:font typeface="Inter"/>
-      <p:bold r:id="rId11"/>
-      <p:italic r:id="rId12"/>
-      <p:boldItalic r:id="rId13"/>
+      <p:bold r:id="rId10"/>
+      <p:italic r:id="rId11"/>
+      <p:boldItalic r:id="rId12"/>
+    </p:embeddedFont>
+    <p:embeddedFont>
+      <p:font typeface="Inter ExtraBold"/>
     </p:embeddedFont>
     <p:embeddedFont>
       <p:font typeface="Microsoft YaHei"/>
@@ -40,8 +39,8 @@
 </file>
 
 <file path=ppt/slideLayouts/slideLayout1.xml><?xml version="1.0" encoding="utf-8"?>
-<p:sldLayout xmlns:a="http://schemas.openxmlformats.org/drawingml/2006/main" xmlns:p="http://schemas.openxmlformats.org/presentationml/2006/main" xmlns:r="http://schemas.openxmlformats.org/officeDocument/2006/relationships" xmlns:p14="http://schemas.microsoft.com/office/powerpoint/2010/main" xmlns:p15="http://schemas.microsoft.com/office/powerpoint/2012/main" xmlns:mc="http://schemas.openxmlformats.org/markup-compatibility/2006" type="title" preserve="1">
-  <p:cSld name="TITLE">
+<p:sldLayout xmlns:a="http://schemas.openxmlformats.org/drawingml/2006/main" xmlns:p="http://schemas.openxmlformats.org/presentationml/2006/main" xmlns:r="http://schemas.openxmlformats.org/officeDocument/2006/relationships" xmlns:p14="http://schemas.microsoft.com/office/powerpoint/2010/main" xmlns:p15="http://schemas.microsoft.com/office/powerpoint/2012/main" xmlns:mc="http://schemas.openxmlformats.org/markup-compatibility/2006" type="blank" preserve="1">
+  <p:cSld name="ONE_COLUMN_TEXT">
     <p:bg>
       <p:bgPr>
         <a:solidFill>
@@ -76,7 +75,7 @@
         <p:spPr>
           <a:xfrm>
             <a:off x="8472600" y="4663080"/>
-            <a:ext cx="548280" cy="393120"/>
+            <a:ext cx="547920" cy="392760"/>
           </a:xfrm>
           <a:prstGeom prst="rect">
             <a:avLst/>
@@ -120,7 +119,7 @@
                 <a:tab algn="l" pos="0"/>
               </a:tabLst>
             </a:pPr>
-            <a:fld id="{065EB3FA-5CE7-4535-8FBD-9692B98CDB65}" type="slidenum">
+            <a:fld id="{182E29DF-7A9A-42A2-BD2F-3B543F9E2F62}" type="slidenum">
               <a:rPr b="0" lang="en" sz="1000" strike="noStrike" u="none">
                 <a:solidFill>
                   <a:schemeClr val="dk2"/>
@@ -139,312 +138,6 @@
               <a:effectLst/>
               <a:uFillTx/>
               <a:latin typeface="Times New Roman"/>
-            </a:endParaRPr>
-          </a:p>
-        </p:txBody>
-      </p:sp>
-      <p:sp>
-        <p:nvSpPr>
-          <p:cNvPr id="3" name="PlaceHolder 2"/>
-          <p:cNvSpPr>
-            <a:spLocks noGrp="1"/>
-          </p:cNvSpPr>
-          <p:nvPr>
-            <p:ph type="title"/>
-          </p:nvPr>
-        </p:nvSpPr>
-        <p:spPr>
-          <a:xfrm>
-            <a:off x="457200" y="205200"/>
-            <a:ext cx="8229240" cy="858600"/>
-          </a:xfrm>
-          <a:prstGeom prst="rect">
-            <a:avLst/>
-          </a:prstGeom>
-          <a:noFill/>
-          <a:ln w="0">
-            <a:noFill/>
-          </a:ln>
-        </p:spPr>
-        <p:txBody>
-          <a:bodyPr lIns="0" rIns="0" tIns="0" bIns="0" anchor="ctr">
-            <a:noAutofit/>
-          </a:bodyPr>
-          <a:p>
-            <a:pPr indent="0">
-              <a:buNone/>
-            </a:pPr>
-            <a:r>
-              <a:rPr b="0" lang="es-MX" sz="1400" strike="noStrike" u="none">
-                <a:solidFill>
-                  <a:srgbClr val="000000"/>
-                </a:solidFill>
-                <a:effectLst/>
-                <a:uFillTx/>
-                <a:latin typeface="Arial"/>
-              </a:rPr>
-              <a:t>Pulse para editar el formato del texto de título</a:t>
-            </a:r>
-            <a:endParaRPr b="0" lang="es-MX" sz="1400" strike="noStrike" u="none">
-              <a:solidFill>
-                <a:srgbClr val="000000"/>
-              </a:solidFill>
-              <a:effectLst/>
-              <a:uFillTx/>
-              <a:latin typeface="Arial"/>
-            </a:endParaRPr>
-          </a:p>
-        </p:txBody>
-      </p:sp>
-      <p:sp>
-        <p:nvSpPr>
-          <p:cNvPr id="4" name="PlaceHolder 3"/>
-          <p:cNvSpPr>
-            <a:spLocks noGrp="1"/>
-          </p:cNvSpPr>
-          <p:nvPr>
-            <p:ph type="body"/>
-          </p:nvPr>
-        </p:nvSpPr>
-        <p:spPr>
-          <a:xfrm>
-            <a:off x="457200" y="1203480"/>
-            <a:ext cx="8229240" cy="2982960"/>
-          </a:xfrm>
-          <a:prstGeom prst="rect">
-            <a:avLst/>
-          </a:prstGeom>
-          <a:noFill/>
-          <a:ln w="0">
-            <a:noFill/>
-          </a:ln>
-        </p:spPr>
-        <p:txBody>
-          <a:bodyPr lIns="0" rIns="0" tIns="0" bIns="0" anchor="t">
-            <a:normAutofit/>
-          </a:bodyPr>
-          <a:p>
-            <a:pPr marL="432000" indent="-324000">
-              <a:spcBef>
-                <a:spcPts val="1417"/>
-              </a:spcBef>
-              <a:buClr>
-                <a:srgbClr val="000000"/>
-              </a:buClr>
-              <a:buSzPct val="45000"/>
-              <a:buFont typeface="Wingdings" charset="2"/>
-              <a:buChar char=""/>
-            </a:pPr>
-            <a:r>
-              <a:rPr b="0" lang="es-MX" sz="1400" strike="noStrike" u="none">
-                <a:solidFill>
-                  <a:srgbClr val="000000"/>
-                </a:solidFill>
-                <a:effectLst/>
-                <a:uFillTx/>
-                <a:latin typeface="Arial"/>
-              </a:rPr>
-              <a:t>Pulse para editar el formato de texto del esquema</a:t>
-            </a:r>
-            <a:endParaRPr b="0" lang="es-MX" sz="1400" strike="noStrike" u="none">
-              <a:solidFill>
-                <a:srgbClr val="000000"/>
-              </a:solidFill>
-              <a:effectLst/>
-              <a:uFillTx/>
-              <a:latin typeface="Arial"/>
-            </a:endParaRPr>
-          </a:p>
-          <a:p>
-            <a:pPr lvl="1" marL="864000" indent="-324000">
-              <a:spcBef>
-                <a:spcPts val="1134"/>
-              </a:spcBef>
-              <a:buClr>
-                <a:srgbClr val="000000"/>
-              </a:buClr>
-              <a:buSzPct val="75000"/>
-              <a:buFont typeface="Symbol" charset="2"/>
-              <a:buChar char=""/>
-            </a:pPr>
-            <a:r>
-              <a:rPr b="0" lang="es-MX" sz="1400" strike="noStrike" u="none">
-                <a:solidFill>
-                  <a:srgbClr val="000000"/>
-                </a:solidFill>
-                <a:effectLst/>
-                <a:uFillTx/>
-                <a:latin typeface="Arial"/>
-              </a:rPr>
-              <a:t>Segundo nivel del esquema</a:t>
-            </a:r>
-            <a:endParaRPr b="0" lang="es-MX" sz="1400" strike="noStrike" u="none">
-              <a:solidFill>
-                <a:srgbClr val="000000"/>
-              </a:solidFill>
-              <a:effectLst/>
-              <a:uFillTx/>
-              <a:latin typeface="Arial"/>
-            </a:endParaRPr>
-          </a:p>
-          <a:p>
-            <a:pPr lvl="2" marL="1296000" indent="-288000">
-              <a:spcBef>
-                <a:spcPts val="850"/>
-              </a:spcBef>
-              <a:buClr>
-                <a:srgbClr val="000000"/>
-              </a:buClr>
-              <a:buSzPct val="45000"/>
-              <a:buFont typeface="Wingdings" charset="2"/>
-              <a:buChar char=""/>
-            </a:pPr>
-            <a:r>
-              <a:rPr b="0" lang="es-MX" sz="1400" strike="noStrike" u="none">
-                <a:solidFill>
-                  <a:srgbClr val="000000"/>
-                </a:solidFill>
-                <a:effectLst/>
-                <a:uFillTx/>
-                <a:latin typeface="Arial"/>
-              </a:rPr>
-              <a:t>Tercer nivel del esquema</a:t>
-            </a:r>
-            <a:endParaRPr b="0" lang="es-MX" sz="1400" strike="noStrike" u="none">
-              <a:solidFill>
-                <a:srgbClr val="000000"/>
-              </a:solidFill>
-              <a:effectLst/>
-              <a:uFillTx/>
-              <a:latin typeface="Arial"/>
-            </a:endParaRPr>
-          </a:p>
-          <a:p>
-            <a:pPr lvl="3" marL="1728000" indent="-216000">
-              <a:spcBef>
-                <a:spcPts val="567"/>
-              </a:spcBef>
-              <a:buClr>
-                <a:srgbClr val="000000"/>
-              </a:buClr>
-              <a:buSzPct val="75000"/>
-              <a:buFont typeface="Symbol" charset="2"/>
-              <a:buChar char=""/>
-            </a:pPr>
-            <a:r>
-              <a:rPr b="0" lang="es-MX" sz="1400" strike="noStrike" u="none">
-                <a:solidFill>
-                  <a:srgbClr val="000000"/>
-                </a:solidFill>
-                <a:effectLst/>
-                <a:uFillTx/>
-                <a:latin typeface="Arial"/>
-              </a:rPr>
-              <a:t>Cuarto nivel del esquema</a:t>
-            </a:r>
-            <a:endParaRPr b="0" lang="es-MX" sz="1400" strike="noStrike" u="none">
-              <a:solidFill>
-                <a:srgbClr val="000000"/>
-              </a:solidFill>
-              <a:effectLst/>
-              <a:uFillTx/>
-              <a:latin typeface="Arial"/>
-            </a:endParaRPr>
-          </a:p>
-          <a:p>
-            <a:pPr lvl="4" marL="2160000" indent="-216000">
-              <a:spcBef>
-                <a:spcPts val="283"/>
-              </a:spcBef>
-              <a:buClr>
-                <a:srgbClr val="000000"/>
-              </a:buClr>
-              <a:buSzPct val="45000"/>
-              <a:buFont typeface="Wingdings" charset="2"/>
-              <a:buChar char=""/>
-            </a:pPr>
-            <a:r>
-              <a:rPr b="0" lang="es-MX" sz="2000" strike="noStrike" u="none">
-                <a:solidFill>
-                  <a:srgbClr val="000000"/>
-                </a:solidFill>
-                <a:effectLst/>
-                <a:uFillTx/>
-                <a:latin typeface="Arial"/>
-              </a:rPr>
-              <a:t>Quinto nivel del esquema</a:t>
-            </a:r>
-            <a:endParaRPr b="0" lang="es-MX" sz="2000" strike="noStrike" u="none">
-              <a:solidFill>
-                <a:srgbClr val="000000"/>
-              </a:solidFill>
-              <a:effectLst/>
-              <a:uFillTx/>
-              <a:latin typeface="Arial"/>
-            </a:endParaRPr>
-          </a:p>
-          <a:p>
-            <a:pPr lvl="5" marL="2592000" indent="-216000">
-              <a:spcBef>
-                <a:spcPts val="283"/>
-              </a:spcBef>
-              <a:buClr>
-                <a:srgbClr val="000000"/>
-              </a:buClr>
-              <a:buSzPct val="45000"/>
-              <a:buFont typeface="Wingdings" charset="2"/>
-              <a:buChar char=""/>
-            </a:pPr>
-            <a:r>
-              <a:rPr b="0" lang="es-MX" sz="2000" strike="noStrike" u="none">
-                <a:solidFill>
-                  <a:srgbClr val="000000"/>
-                </a:solidFill>
-                <a:effectLst/>
-                <a:uFillTx/>
-                <a:latin typeface="Arial"/>
-              </a:rPr>
-              <a:t>Sexto nivel del esquema</a:t>
-            </a:r>
-            <a:endParaRPr b="0" lang="es-MX" sz="2000" strike="noStrike" u="none">
-              <a:solidFill>
-                <a:srgbClr val="000000"/>
-              </a:solidFill>
-              <a:effectLst/>
-              <a:uFillTx/>
-              <a:latin typeface="Arial"/>
-            </a:endParaRPr>
-          </a:p>
-          <a:p>
-            <a:pPr lvl="6" marL="3024000" indent="-216000">
-              <a:spcBef>
-                <a:spcPts val="283"/>
-              </a:spcBef>
-              <a:buClr>
-                <a:srgbClr val="000000"/>
-              </a:buClr>
-              <a:buSzPct val="45000"/>
-              <a:buFont typeface="Wingdings" charset="2"/>
-              <a:buChar char=""/>
-            </a:pPr>
-            <a:r>
-              <a:rPr b="0" lang="es-MX" sz="2000" strike="noStrike" u="none">
-                <a:solidFill>
-                  <a:srgbClr val="000000"/>
-                </a:solidFill>
-                <a:effectLst/>
-                <a:uFillTx/>
-                <a:latin typeface="Arial"/>
-              </a:rPr>
-              <a:t>Séptimo nivel del esquema</a:t>
-            </a:r>
-            <a:endParaRPr b="0" lang="es-MX" sz="2000" strike="noStrike" u="none">
-              <a:solidFill>
-                <a:srgbClr val="000000"/>
-              </a:solidFill>
-              <a:effectLst/>
-              <a:uFillTx/>
-              <a:latin typeface="Arial"/>
             </a:endParaRPr>
           </a:p>
         </p:txBody>
@@ -455,8 +148,8 @@
 </file>
 
 <file path=ppt/slideLayouts/slideLayout10.xml><?xml version="1.0" encoding="utf-8"?>
-<p:sldLayout xmlns:a="http://schemas.openxmlformats.org/drawingml/2006/main" xmlns:p="http://schemas.openxmlformats.org/presentationml/2006/main" xmlns:r="http://schemas.openxmlformats.org/officeDocument/2006/relationships" xmlns:p14="http://schemas.microsoft.com/office/powerpoint/2010/main" xmlns:p15="http://schemas.microsoft.com/office/powerpoint/2012/main" xmlns:mc="http://schemas.openxmlformats.org/markup-compatibility/2006" type="blank" preserve="1">
-  <p:cSld name="MAIN_POINT">
+<p:sldLayout xmlns:a="http://schemas.openxmlformats.org/drawingml/2006/main" xmlns:p="http://schemas.openxmlformats.org/presentationml/2006/main" xmlns:r="http://schemas.openxmlformats.org/officeDocument/2006/relationships" xmlns:p14="http://schemas.microsoft.com/office/powerpoint/2010/main" xmlns:p15="http://schemas.microsoft.com/office/powerpoint/2012/main" xmlns:mc="http://schemas.openxmlformats.org/markup-compatibility/2006" type="tx" preserve="1">
+  <p:cSld name="TITLE_AND_BODY">
     <p:bg>
       <p:bgPr>
         <a:solidFill>
@@ -491,7 +184,7 @@
         <p:spPr>
           <a:xfrm>
             <a:off x="8472600" y="4663080"/>
-            <a:ext cx="548280" cy="393120"/>
+            <a:ext cx="547920" cy="392760"/>
           </a:xfrm>
           <a:prstGeom prst="rect">
             <a:avLst/>
@@ -535,7 +228,7 @@
                 <a:tab algn="l" pos="0"/>
               </a:tabLst>
             </a:pPr>
-            <a:fld id="{44CF6334-EB41-4E5A-877F-C21DB11D11A4}" type="slidenum">
+            <a:fld id="{DE9C57A0-5B88-4B7D-9D97-7C95EBDD77A5}" type="slidenum">
               <a:rPr b="0" lang="en" sz="1000" strike="noStrike" u="none">
                 <a:solidFill>
                   <a:schemeClr val="dk2"/>
@@ -564,8 +257,8 @@
 </file>
 
 <file path=ppt/slideLayouts/slideLayout11.xml><?xml version="1.0" encoding="utf-8"?>
-<p:sldLayout xmlns:a="http://schemas.openxmlformats.org/drawingml/2006/main" xmlns:p="http://schemas.openxmlformats.org/presentationml/2006/main" xmlns:r="http://schemas.openxmlformats.org/officeDocument/2006/relationships" xmlns:p14="http://schemas.microsoft.com/office/powerpoint/2010/main" xmlns:p15="http://schemas.microsoft.com/office/powerpoint/2012/main" xmlns:mc="http://schemas.openxmlformats.org/markup-compatibility/2006" type="blank" preserve="1">
-  <p:cSld name="SECTION_TITLE_AND_DESCRIPTION">
+<p:sldLayout xmlns:a="http://schemas.openxmlformats.org/drawingml/2006/main" xmlns:p="http://schemas.openxmlformats.org/presentationml/2006/main" xmlns:r="http://schemas.openxmlformats.org/officeDocument/2006/relationships" xmlns:p14="http://schemas.microsoft.com/office/powerpoint/2010/main" xmlns:p15="http://schemas.microsoft.com/office/powerpoint/2012/main" xmlns:mc="http://schemas.openxmlformats.org/markup-compatibility/2006" type="twoObj" preserve="1">
+  <p:cSld name="TITLE_AND_TWO_COLUMNS">
     <p:bg>
       <p:bgPr>
         <a:solidFill>
@@ -600,7 +293,7 @@
         <p:spPr>
           <a:xfrm>
             <a:off x="8472600" y="4663080"/>
-            <a:ext cx="548280" cy="393120"/>
+            <a:ext cx="547920" cy="392760"/>
           </a:xfrm>
           <a:prstGeom prst="rect">
             <a:avLst/>
@@ -644,7 +337,7 @@
                 <a:tab algn="l" pos="0"/>
               </a:tabLst>
             </a:pPr>
-            <a:fld id="{27ECEAF7-116E-44AB-81EC-9F9E6D304405}" type="slidenum">
+            <a:fld id="{0B5ADCB5-F06F-4B09-AD01-5D8BE5CA2946}" type="slidenum">
               <a:rPr b="0" lang="en" sz="1000" strike="noStrike" u="none">
                 <a:solidFill>
                   <a:schemeClr val="dk2"/>
@@ -673,8 +366,8 @@
 </file>
 
 <file path=ppt/slideLayouts/slideLayout12.xml><?xml version="1.0" encoding="utf-8"?>
-<p:sldLayout xmlns:a="http://schemas.openxmlformats.org/drawingml/2006/main" xmlns:p="http://schemas.openxmlformats.org/presentationml/2006/main" xmlns:r="http://schemas.openxmlformats.org/officeDocument/2006/relationships" xmlns:p14="http://schemas.microsoft.com/office/powerpoint/2010/main" xmlns:p15="http://schemas.microsoft.com/office/powerpoint/2012/main" xmlns:mc="http://schemas.openxmlformats.org/markup-compatibility/2006" type="blank" preserve="1">
-  <p:cSld name="CAPTION_ONLY">
+<p:sldLayout xmlns:a="http://schemas.openxmlformats.org/drawingml/2006/main" xmlns:p="http://schemas.openxmlformats.org/presentationml/2006/main" xmlns:r="http://schemas.openxmlformats.org/officeDocument/2006/relationships" xmlns:p14="http://schemas.microsoft.com/office/powerpoint/2010/main" xmlns:p15="http://schemas.microsoft.com/office/powerpoint/2012/main" xmlns:mc="http://schemas.openxmlformats.org/markup-compatibility/2006" type="titleOnly" preserve="1">
+  <p:cSld name="TITLE_ONLY">
     <p:bg>
       <p:bgPr>
         <a:solidFill>
@@ -709,7 +402,7 @@
         <p:spPr>
           <a:xfrm>
             <a:off x="8472600" y="4663080"/>
-            <a:ext cx="548280" cy="393120"/>
+            <a:ext cx="547920" cy="392760"/>
           </a:xfrm>
           <a:prstGeom prst="rect">
             <a:avLst/>
@@ -721,12 +414,50 @@
         </p:spPr>
         <p:txBody>
           <a:bodyPr lIns="91440" rIns="91440" tIns="91440" bIns="91440" anchor="ctr">
-            <a:normAutofit fontScale="55000" lnSpcReduction="19999"/>
+            <a:normAutofit/>
           </a:bodyPr>
-          <a:p>
-            <a:pPr indent="0">
+          <a:lstStyle>
+            <a:lvl1pPr indent="0" algn="r">
+              <a:lnSpc>
+                <a:spcPct val="100000"/>
+              </a:lnSpc>
               <a:buNone/>
-            </a:pPr>
+              <a:tabLst>
+                <a:tab algn="l" pos="0"/>
+              </a:tabLst>
+              <a:defRPr b="0" lang="en" sz="1000" strike="noStrike" u="none">
+                <a:solidFill>
+                  <a:schemeClr val="dk2"/>
+                </a:solidFill>
+                <a:effectLst/>
+                <a:uFillTx/>
+                <a:latin typeface="Arial"/>
+                <a:ea typeface="Arial"/>
+              </a:defRPr>
+            </a:lvl1pPr>
+          </a:lstStyle>
+          <a:p>
+            <a:pPr indent="0" algn="r">
+              <a:lnSpc>
+                <a:spcPct val="100000"/>
+              </a:lnSpc>
+              <a:buNone/>
+              <a:tabLst>
+                <a:tab algn="l" pos="0"/>
+              </a:tabLst>
+            </a:pPr>
+            <a:fld id="{4BB7CA03-0CEF-4655-B461-ABBE85245504}" type="slidenum">
+              <a:rPr b="0" lang="en" sz="1000" strike="noStrike" u="none">
+                <a:solidFill>
+                  <a:schemeClr val="dk2"/>
+                </a:solidFill>
+                <a:effectLst/>
+                <a:uFillTx/>
+                <a:latin typeface="Arial"/>
+                <a:ea typeface="Arial"/>
+              </a:rPr>
+              <a:t>&lt;número&gt;</a:t>
+            </a:fld>
             <a:endParaRPr b="0" lang="es-MX" sz="1000" strike="noStrike" u="none">
               <a:solidFill>
                 <a:srgbClr val="000000"/>
@@ -745,7 +476,225 @@
 
 <file path=ppt/slideLayouts/slideLayout2.xml><?xml version="1.0" encoding="utf-8"?>
 <p:sldLayout xmlns:a="http://schemas.openxmlformats.org/drawingml/2006/main" xmlns:p="http://schemas.openxmlformats.org/presentationml/2006/main" xmlns:r="http://schemas.openxmlformats.org/officeDocument/2006/relationships" xmlns:p14="http://schemas.microsoft.com/office/powerpoint/2010/main" xmlns:p15="http://schemas.microsoft.com/office/powerpoint/2012/main" xmlns:mc="http://schemas.openxmlformats.org/markup-compatibility/2006" type="blank" preserve="1">
-  <p:cSld name="BIG_NUMBER">
+  <p:cSld name="MAIN_POINT">
+    <p:bg>
+      <p:bgPr>
+        <a:solidFill>
+          <a:schemeClr val="lt1"/>
+        </a:solidFill>
+      </p:bgPr>
+    </p:bg>
+    <p:spTree>
+      <p:nvGrpSpPr>
+        <p:cNvPr id="1" name=""/>
+        <p:cNvGrpSpPr/>
+        <p:nvPr/>
+      </p:nvGrpSpPr>
+      <p:grpSpPr>
+        <a:xfrm>
+          <a:off x="0" y="0"/>
+          <a:ext cx="0" cy="0"/>
+          <a:chOff x="0" y="0"/>
+          <a:chExt cx="0" cy="0"/>
+        </a:xfrm>
+      </p:grpSpPr>
+      <p:sp>
+        <p:nvSpPr>
+          <p:cNvPr id="3" name="PlaceHolder 1"/>
+          <p:cNvSpPr>
+            <a:spLocks noGrp="1"/>
+          </p:cNvSpPr>
+          <p:nvPr>
+            <p:ph type="sldNum" idx="2"/>
+          </p:nvPr>
+        </p:nvSpPr>
+        <p:spPr>
+          <a:xfrm>
+            <a:off x="8472600" y="4663080"/>
+            <a:ext cx="547920" cy="392760"/>
+          </a:xfrm>
+          <a:prstGeom prst="rect">
+            <a:avLst/>
+          </a:prstGeom>
+          <a:noFill/>
+          <a:ln w="0">
+            <a:noFill/>
+          </a:ln>
+        </p:spPr>
+        <p:txBody>
+          <a:bodyPr lIns="91440" rIns="91440" tIns="91440" bIns="91440" anchor="ctr">
+            <a:normAutofit/>
+          </a:bodyPr>
+          <a:lstStyle>
+            <a:lvl1pPr indent="0" algn="r">
+              <a:lnSpc>
+                <a:spcPct val="100000"/>
+              </a:lnSpc>
+              <a:buNone/>
+              <a:tabLst>
+                <a:tab algn="l" pos="0"/>
+              </a:tabLst>
+              <a:defRPr b="0" lang="en" sz="1000" strike="noStrike" u="none">
+                <a:solidFill>
+                  <a:schemeClr val="dk2"/>
+                </a:solidFill>
+                <a:effectLst/>
+                <a:uFillTx/>
+                <a:latin typeface="Arial"/>
+                <a:ea typeface="Arial"/>
+              </a:defRPr>
+            </a:lvl1pPr>
+          </a:lstStyle>
+          <a:p>
+            <a:pPr indent="0" algn="r">
+              <a:lnSpc>
+                <a:spcPct val="100000"/>
+              </a:lnSpc>
+              <a:buNone/>
+              <a:tabLst>
+                <a:tab algn="l" pos="0"/>
+              </a:tabLst>
+            </a:pPr>
+            <a:fld id="{93D584BE-E7B6-4F65-87B5-847C5AEE694D}" type="slidenum">
+              <a:rPr b="0" lang="en" sz="1000" strike="noStrike" u="none">
+                <a:solidFill>
+                  <a:schemeClr val="dk2"/>
+                </a:solidFill>
+                <a:effectLst/>
+                <a:uFillTx/>
+                <a:latin typeface="Arial"/>
+                <a:ea typeface="Arial"/>
+              </a:rPr>
+              <a:t>&lt;número&gt;</a:t>
+            </a:fld>
+            <a:endParaRPr b="0" lang="es-MX" sz="1000" strike="noStrike" u="none">
+              <a:solidFill>
+                <a:srgbClr val="000000"/>
+              </a:solidFill>
+              <a:effectLst/>
+              <a:uFillTx/>
+              <a:latin typeface="Times New Roman"/>
+            </a:endParaRPr>
+          </a:p>
+        </p:txBody>
+      </p:sp>
+    </p:spTree>
+  </p:cSld>
+</p:sldLayout>
+</file>
+
+<file path=ppt/slideLayouts/slideLayout3.xml><?xml version="1.0" encoding="utf-8"?>
+<p:sldLayout xmlns:a="http://schemas.openxmlformats.org/drawingml/2006/main" xmlns:p="http://schemas.openxmlformats.org/presentationml/2006/main" xmlns:r="http://schemas.openxmlformats.org/officeDocument/2006/relationships" xmlns:p14="http://schemas.microsoft.com/office/powerpoint/2010/main" xmlns:p15="http://schemas.microsoft.com/office/powerpoint/2012/main" xmlns:mc="http://schemas.openxmlformats.org/markup-compatibility/2006" type="blank" preserve="1">
+  <p:cSld name="SECTION_TITLE_AND_DESCRIPTION">
+    <p:bg>
+      <p:bgPr>
+        <a:solidFill>
+          <a:schemeClr val="lt1"/>
+        </a:solidFill>
+      </p:bgPr>
+    </p:bg>
+    <p:spTree>
+      <p:nvGrpSpPr>
+        <p:cNvPr id="1" name=""/>
+        <p:cNvGrpSpPr/>
+        <p:nvPr/>
+      </p:nvGrpSpPr>
+      <p:grpSpPr>
+        <a:xfrm>
+          <a:off x="0" y="0"/>
+          <a:ext cx="0" cy="0"/>
+          <a:chOff x="0" y="0"/>
+          <a:chExt cx="0" cy="0"/>
+        </a:xfrm>
+      </p:grpSpPr>
+      <p:sp>
+        <p:nvSpPr>
+          <p:cNvPr id="4" name="PlaceHolder 1"/>
+          <p:cNvSpPr>
+            <a:spLocks noGrp="1"/>
+          </p:cNvSpPr>
+          <p:nvPr>
+            <p:ph type="sldNum" idx="3"/>
+          </p:nvPr>
+        </p:nvSpPr>
+        <p:spPr>
+          <a:xfrm>
+            <a:off x="8472600" y="4663080"/>
+            <a:ext cx="547920" cy="392760"/>
+          </a:xfrm>
+          <a:prstGeom prst="rect">
+            <a:avLst/>
+          </a:prstGeom>
+          <a:noFill/>
+          <a:ln w="0">
+            <a:noFill/>
+          </a:ln>
+        </p:spPr>
+        <p:txBody>
+          <a:bodyPr lIns="91440" rIns="91440" tIns="91440" bIns="91440" anchor="ctr">
+            <a:normAutofit/>
+          </a:bodyPr>
+          <a:lstStyle>
+            <a:lvl1pPr indent="0" algn="r">
+              <a:lnSpc>
+                <a:spcPct val="100000"/>
+              </a:lnSpc>
+              <a:buNone/>
+              <a:tabLst>
+                <a:tab algn="l" pos="0"/>
+              </a:tabLst>
+              <a:defRPr b="0" lang="en" sz="1000" strike="noStrike" u="none">
+                <a:solidFill>
+                  <a:schemeClr val="dk2"/>
+                </a:solidFill>
+                <a:effectLst/>
+                <a:uFillTx/>
+                <a:latin typeface="Arial"/>
+                <a:ea typeface="Arial"/>
+              </a:defRPr>
+            </a:lvl1pPr>
+          </a:lstStyle>
+          <a:p>
+            <a:pPr indent="0" algn="r">
+              <a:lnSpc>
+                <a:spcPct val="100000"/>
+              </a:lnSpc>
+              <a:buNone/>
+              <a:tabLst>
+                <a:tab algn="l" pos="0"/>
+              </a:tabLst>
+            </a:pPr>
+            <a:fld id="{BB02F3AC-4B55-4399-98D4-EA8EDC86AC55}" type="slidenum">
+              <a:rPr b="0" lang="en" sz="1000" strike="noStrike" u="none">
+                <a:solidFill>
+                  <a:schemeClr val="dk2"/>
+                </a:solidFill>
+                <a:effectLst/>
+                <a:uFillTx/>
+                <a:latin typeface="Arial"/>
+                <a:ea typeface="Arial"/>
+              </a:rPr>
+              <a:t>&lt;número&gt;</a:t>
+            </a:fld>
+            <a:endParaRPr b="0" lang="es-MX" sz="1000" strike="noStrike" u="none">
+              <a:solidFill>
+                <a:srgbClr val="000000"/>
+              </a:solidFill>
+              <a:effectLst/>
+              <a:uFillTx/>
+              <a:latin typeface="Times New Roman"/>
+            </a:endParaRPr>
+          </a:p>
+        </p:txBody>
+      </p:sp>
+    </p:spTree>
+  </p:cSld>
+</p:sldLayout>
+</file>
+
+<file path=ppt/slideLayouts/slideLayout4.xml><?xml version="1.0" encoding="utf-8"?>
+<p:sldLayout xmlns:a="http://schemas.openxmlformats.org/drawingml/2006/main" xmlns:p="http://schemas.openxmlformats.org/presentationml/2006/main" xmlns:r="http://schemas.openxmlformats.org/officeDocument/2006/relationships" xmlns:p14="http://schemas.microsoft.com/office/powerpoint/2010/main" xmlns:p15="http://schemas.microsoft.com/office/powerpoint/2012/main" xmlns:mc="http://schemas.openxmlformats.org/markup-compatibility/2006" type="blank" preserve="1">
+  <p:cSld name="CAPTION_ONLY">
     <p:bg>
       <p:bgPr>
         <a:solidFill>
@@ -774,13 +723,13 @@
             <a:spLocks noGrp="1"/>
           </p:cNvSpPr>
           <p:nvPr>
-            <p:ph type="sldNum" idx="2"/>
+            <p:ph type="sldNum" idx="4"/>
           </p:nvPr>
         </p:nvSpPr>
         <p:spPr>
           <a:xfrm>
             <a:off x="8472600" y="4663080"/>
-            <a:ext cx="548280" cy="393120"/>
+            <a:ext cx="547920" cy="392760"/>
           </a:xfrm>
           <a:prstGeom prst="rect">
             <a:avLst/>
@@ -792,51 +741,13 @@
         </p:spPr>
         <p:txBody>
           <a:bodyPr lIns="91440" rIns="91440" tIns="91440" bIns="91440" anchor="ctr">
-            <a:normAutofit/>
+            <a:normAutofit fontScale="55000" lnSpcReduction="19999"/>
           </a:bodyPr>
-          <a:lstStyle>
-            <a:lvl1pPr indent="0" algn="r">
-              <a:lnSpc>
-                <a:spcPct val="100000"/>
-              </a:lnSpc>
+          <a:p>
+            <a:pPr indent="0">
               <a:buNone/>
-              <a:tabLst>
-                <a:tab algn="l" pos="0"/>
-              </a:tabLst>
-              <a:defRPr b="0" lang="en" sz="1000" strike="noStrike" u="none">
-                <a:solidFill>
-                  <a:schemeClr val="dk2"/>
-                </a:solidFill>
-                <a:effectLst/>
-                <a:uFillTx/>
-                <a:latin typeface="Arial"/>
-                <a:ea typeface="Arial"/>
-              </a:defRPr>
-            </a:lvl1pPr>
-          </a:lstStyle>
-          <a:p>
-            <a:pPr indent="0" algn="r">
-              <a:lnSpc>
-                <a:spcPct val="100000"/>
-              </a:lnSpc>
-              <a:buNone/>
-              <a:tabLst>
-                <a:tab algn="l" pos="0"/>
-              </a:tabLst>
-            </a:pPr>
-            <a:fld id="{30F45FE2-CEA0-4610-993F-612916F06AC9}" type="slidenum">
-              <a:rPr b="0" lang="en" sz="1000" strike="noStrike" u="none">
-                <a:solidFill>
-                  <a:schemeClr val="dk2"/>
-                </a:solidFill>
-                <a:effectLst/>
-                <a:uFillTx/>
-                <a:latin typeface="Arial"/>
-                <a:ea typeface="Arial"/>
-              </a:rPr>
-              <a:t>&lt;número&gt;</a:t>
-            </a:fld>
-            <a:endParaRPr b="0" lang="es-MX" sz="1000" strike="noStrike" u="none">
+            </a:pPr>
+            <a:endParaRPr b="0" lang="es-MX" sz="1800" strike="noStrike" u="none">
               <a:solidFill>
                 <a:srgbClr val="000000"/>
               </a:solidFill>
@@ -852,9 +763,9 @@
 </p:sldLayout>
 </file>
 
-<file path=ppt/slideLayouts/slideLayout3.xml><?xml version="1.0" encoding="utf-8"?>
-<p:sldLayout xmlns:a="http://schemas.openxmlformats.org/drawingml/2006/main" xmlns:p="http://schemas.openxmlformats.org/presentationml/2006/main" xmlns:r="http://schemas.openxmlformats.org/officeDocument/2006/relationships" xmlns:p14="http://schemas.microsoft.com/office/powerpoint/2010/main" xmlns:p15="http://schemas.microsoft.com/office/powerpoint/2012/main" xmlns:mc="http://schemas.openxmlformats.org/markup-compatibility/2006" type="blank" preserve="1">
-  <p:cSld name="BLANK">
+<file path=ppt/slideLayouts/slideLayout5.xml><?xml version="1.0" encoding="utf-8"?>
+<p:sldLayout xmlns:a="http://schemas.openxmlformats.org/drawingml/2006/main" xmlns:p="http://schemas.openxmlformats.org/presentationml/2006/main" xmlns:r="http://schemas.openxmlformats.org/officeDocument/2006/relationships" xmlns:p14="http://schemas.microsoft.com/office/powerpoint/2010/main" xmlns:p15="http://schemas.microsoft.com/office/powerpoint/2012/main" xmlns:mc="http://schemas.openxmlformats.org/markup-compatibility/2006" type="title" preserve="1">
+  <p:cSld name="TITLE">
     <p:bg>
       <p:bgPr>
         <a:solidFill>
@@ -883,13 +794,13 @@
             <a:spLocks noGrp="1"/>
           </p:cNvSpPr>
           <p:nvPr>
-            <p:ph type="sldNum" idx="3"/>
+            <p:ph type="sldNum" idx="5"/>
           </p:nvPr>
         </p:nvSpPr>
         <p:spPr>
           <a:xfrm>
             <a:off x="8472600" y="4663080"/>
-            <a:ext cx="548280" cy="393120"/>
+            <a:ext cx="547920" cy="392760"/>
           </a:xfrm>
           <a:prstGeom prst="rect">
             <a:avLst/>
@@ -933,7 +844,7 @@
                 <a:tab algn="l" pos="0"/>
               </a:tabLst>
             </a:pPr>
-            <a:fld id="{946C9A8C-5599-4E4F-9E94-5D66CAB41129}" type="slidenum">
+            <a:fld id="{C318F6CB-B5FE-436B-8D8D-CEAD62F729FB}" type="slidenum">
               <a:rPr b="0" lang="en" sz="1000" strike="noStrike" u="none">
                 <a:solidFill>
                   <a:schemeClr val="dk2"/>
@@ -969,7 +880,7 @@
         <p:spPr>
           <a:xfrm>
             <a:off x="457200" y="205200"/>
-            <a:ext cx="8229240" cy="858600"/>
+            <a:ext cx="8228880" cy="858240"/>
           </a:xfrm>
           <a:prstGeom prst="rect">
             <a:avLst/>
@@ -985,7 +896,13 @@
           </a:bodyPr>
           <a:p>
             <a:pPr indent="0">
+              <a:lnSpc>
+                <a:spcPct val="100000"/>
+              </a:lnSpc>
               <a:buNone/>
+              <a:tabLst>
+                <a:tab algn="l" pos="0"/>
+              </a:tabLst>
             </a:pPr>
             <a:r>
               <a:rPr b="0" lang="es-MX" sz="1400" strike="noStrike" u="none">
@@ -1022,7 +939,7 @@
         <p:spPr>
           <a:xfrm>
             <a:off x="457200" y="1203480"/>
-            <a:ext cx="8229240" cy="2982960"/>
+            <a:ext cx="8228880" cy="2982600"/>
           </a:xfrm>
           <a:prstGeom prst="rect">
             <a:avLst/>
@@ -1038,6 +955,9 @@
           </a:bodyPr>
           <a:p>
             <a:pPr marL="432000" indent="-324000">
+              <a:lnSpc>
+                <a:spcPct val="100000"/>
+              </a:lnSpc>
               <a:spcBef>
                 <a:spcPts val="1417"/>
               </a:spcBef>
@@ -1070,6 +990,9 @@
           </a:p>
           <a:p>
             <a:pPr lvl="1" marL="864000" indent="-324000">
+              <a:lnSpc>
+                <a:spcPct val="100000"/>
+              </a:lnSpc>
               <a:spcBef>
                 <a:spcPts val="1134"/>
               </a:spcBef>
@@ -1102,6 +1025,9 @@
           </a:p>
           <a:p>
             <a:pPr lvl="2" marL="1296000" indent="-288000">
+              <a:lnSpc>
+                <a:spcPct val="100000"/>
+              </a:lnSpc>
               <a:spcBef>
                 <a:spcPts val="850"/>
               </a:spcBef>
@@ -1134,6 +1060,9 @@
           </a:p>
           <a:p>
             <a:pPr lvl="3" marL="1728000" indent="-216000">
+              <a:lnSpc>
+                <a:spcPct val="100000"/>
+              </a:lnSpc>
               <a:spcBef>
                 <a:spcPts val="567"/>
               </a:spcBef>
@@ -1166,6 +1095,9 @@
           </a:p>
           <a:p>
             <a:pPr lvl="4" marL="2160000" indent="-216000">
+              <a:lnSpc>
+                <a:spcPct val="100000"/>
+              </a:lnSpc>
               <a:spcBef>
                 <a:spcPts val="283"/>
               </a:spcBef>
@@ -1198,6 +1130,9 @@
           </a:p>
           <a:p>
             <a:pPr lvl="5" marL="2592000" indent="-216000">
+              <a:lnSpc>
+                <a:spcPct val="100000"/>
+              </a:lnSpc>
               <a:spcBef>
                 <a:spcPts val="283"/>
               </a:spcBef>
@@ -1230,6 +1165,9 @@
           </a:p>
           <a:p>
             <a:pPr lvl="6" marL="3024000" indent="-216000">
+              <a:lnSpc>
+                <a:spcPct val="100000"/>
+              </a:lnSpc>
               <a:spcBef>
                 <a:spcPts val="283"/>
               </a:spcBef>
@@ -1267,7 +1205,558 @@
 </p:sldLayout>
 </file>
 
-<file path=ppt/slideLayouts/slideLayout4.xml><?xml version="1.0" encoding="utf-8"?>
+<file path=ppt/slideLayouts/slideLayout6.xml><?xml version="1.0" encoding="utf-8"?>
+<p:sldLayout xmlns:a="http://schemas.openxmlformats.org/drawingml/2006/main" xmlns:p="http://schemas.openxmlformats.org/presentationml/2006/main" xmlns:r="http://schemas.openxmlformats.org/officeDocument/2006/relationships" xmlns:p14="http://schemas.microsoft.com/office/powerpoint/2010/main" xmlns:p15="http://schemas.microsoft.com/office/powerpoint/2012/main" xmlns:mc="http://schemas.openxmlformats.org/markup-compatibility/2006" type="blank" preserve="1">
+  <p:cSld name="BIG_NUMBER">
+    <p:bg>
+      <p:bgPr>
+        <a:solidFill>
+          <a:schemeClr val="lt1"/>
+        </a:solidFill>
+      </p:bgPr>
+    </p:bg>
+    <p:spTree>
+      <p:nvGrpSpPr>
+        <p:cNvPr id="1" name=""/>
+        <p:cNvGrpSpPr/>
+        <p:nvPr/>
+      </p:nvGrpSpPr>
+      <p:grpSpPr>
+        <a:xfrm>
+          <a:off x="0" y="0"/>
+          <a:ext cx="0" cy="0"/>
+          <a:chOff x="0" y="0"/>
+          <a:chExt cx="0" cy="0"/>
+        </a:xfrm>
+      </p:grpSpPr>
+      <p:sp>
+        <p:nvSpPr>
+          <p:cNvPr id="9" name="PlaceHolder 1"/>
+          <p:cNvSpPr>
+            <a:spLocks noGrp="1"/>
+          </p:cNvSpPr>
+          <p:nvPr>
+            <p:ph type="sldNum" idx="6"/>
+          </p:nvPr>
+        </p:nvSpPr>
+        <p:spPr>
+          <a:xfrm>
+            <a:off x="8472600" y="4663080"/>
+            <a:ext cx="547920" cy="392760"/>
+          </a:xfrm>
+          <a:prstGeom prst="rect">
+            <a:avLst/>
+          </a:prstGeom>
+          <a:noFill/>
+          <a:ln w="0">
+            <a:noFill/>
+          </a:ln>
+        </p:spPr>
+        <p:txBody>
+          <a:bodyPr lIns="91440" rIns="91440" tIns="91440" bIns="91440" anchor="ctr">
+            <a:normAutofit/>
+          </a:bodyPr>
+          <a:lstStyle>
+            <a:lvl1pPr indent="0" algn="r">
+              <a:lnSpc>
+                <a:spcPct val="100000"/>
+              </a:lnSpc>
+              <a:buNone/>
+              <a:tabLst>
+                <a:tab algn="l" pos="0"/>
+              </a:tabLst>
+              <a:defRPr b="0" lang="en" sz="1000" strike="noStrike" u="none">
+                <a:solidFill>
+                  <a:schemeClr val="dk2"/>
+                </a:solidFill>
+                <a:effectLst/>
+                <a:uFillTx/>
+                <a:latin typeface="Arial"/>
+                <a:ea typeface="Arial"/>
+              </a:defRPr>
+            </a:lvl1pPr>
+          </a:lstStyle>
+          <a:p>
+            <a:pPr indent="0" algn="r">
+              <a:lnSpc>
+                <a:spcPct val="100000"/>
+              </a:lnSpc>
+              <a:buNone/>
+              <a:tabLst>
+                <a:tab algn="l" pos="0"/>
+              </a:tabLst>
+            </a:pPr>
+            <a:fld id="{2A291AAF-812B-4C1A-90F3-CE6B73550F7C}" type="slidenum">
+              <a:rPr b="0" lang="en" sz="1000" strike="noStrike" u="none">
+                <a:solidFill>
+                  <a:schemeClr val="dk2"/>
+                </a:solidFill>
+                <a:effectLst/>
+                <a:uFillTx/>
+                <a:latin typeface="Arial"/>
+                <a:ea typeface="Arial"/>
+              </a:rPr>
+              <a:t>&lt;número&gt;</a:t>
+            </a:fld>
+            <a:endParaRPr b="0" lang="es-MX" sz="1000" strike="noStrike" u="none">
+              <a:solidFill>
+                <a:srgbClr val="000000"/>
+              </a:solidFill>
+              <a:effectLst/>
+              <a:uFillTx/>
+              <a:latin typeface="Times New Roman"/>
+            </a:endParaRPr>
+          </a:p>
+        </p:txBody>
+      </p:sp>
+    </p:spTree>
+  </p:cSld>
+</p:sldLayout>
+</file>
+
+<file path=ppt/slideLayouts/slideLayout7.xml><?xml version="1.0" encoding="utf-8"?>
+<p:sldLayout xmlns:a="http://schemas.openxmlformats.org/drawingml/2006/main" xmlns:p="http://schemas.openxmlformats.org/presentationml/2006/main" xmlns:r="http://schemas.openxmlformats.org/officeDocument/2006/relationships" xmlns:p14="http://schemas.microsoft.com/office/powerpoint/2010/main" xmlns:p15="http://schemas.microsoft.com/office/powerpoint/2012/main" xmlns:mc="http://schemas.openxmlformats.org/markup-compatibility/2006" type="blank" preserve="1">
+  <p:cSld name="BLANK">
+    <p:bg>
+      <p:bgPr>
+        <a:solidFill>
+          <a:schemeClr val="lt1"/>
+        </a:solidFill>
+      </p:bgPr>
+    </p:bg>
+    <p:spTree>
+      <p:nvGrpSpPr>
+        <p:cNvPr id="1" name=""/>
+        <p:cNvGrpSpPr/>
+        <p:nvPr/>
+      </p:nvGrpSpPr>
+      <p:grpSpPr>
+        <a:xfrm>
+          <a:off x="0" y="0"/>
+          <a:ext cx="0" cy="0"/>
+          <a:chOff x="0" y="0"/>
+          <a:chExt cx="0" cy="0"/>
+        </a:xfrm>
+      </p:grpSpPr>
+      <p:sp>
+        <p:nvSpPr>
+          <p:cNvPr id="10" name="PlaceHolder 1"/>
+          <p:cNvSpPr>
+            <a:spLocks noGrp="1"/>
+          </p:cNvSpPr>
+          <p:nvPr>
+            <p:ph type="sldNum" idx="7"/>
+          </p:nvPr>
+        </p:nvSpPr>
+        <p:spPr>
+          <a:xfrm>
+            <a:off x="8472600" y="4663080"/>
+            <a:ext cx="547920" cy="392760"/>
+          </a:xfrm>
+          <a:prstGeom prst="rect">
+            <a:avLst/>
+          </a:prstGeom>
+          <a:noFill/>
+          <a:ln w="0">
+            <a:noFill/>
+          </a:ln>
+        </p:spPr>
+        <p:txBody>
+          <a:bodyPr lIns="91440" rIns="91440" tIns="91440" bIns="91440" anchor="ctr">
+            <a:normAutofit/>
+          </a:bodyPr>
+          <a:lstStyle>
+            <a:lvl1pPr indent="0" algn="r">
+              <a:lnSpc>
+                <a:spcPct val="100000"/>
+              </a:lnSpc>
+              <a:buNone/>
+              <a:tabLst>
+                <a:tab algn="l" pos="0"/>
+              </a:tabLst>
+              <a:defRPr b="0" lang="en" sz="1000" strike="noStrike" u="none">
+                <a:solidFill>
+                  <a:schemeClr val="dk2"/>
+                </a:solidFill>
+                <a:effectLst/>
+                <a:uFillTx/>
+                <a:latin typeface="Arial"/>
+                <a:ea typeface="Arial"/>
+              </a:defRPr>
+            </a:lvl1pPr>
+          </a:lstStyle>
+          <a:p>
+            <a:pPr indent="0" algn="r">
+              <a:lnSpc>
+                <a:spcPct val="100000"/>
+              </a:lnSpc>
+              <a:buNone/>
+              <a:tabLst>
+                <a:tab algn="l" pos="0"/>
+              </a:tabLst>
+            </a:pPr>
+            <a:fld id="{38D84B2E-E441-4876-B313-667D2A012DF4}" type="slidenum">
+              <a:rPr b="0" lang="en" sz="1000" strike="noStrike" u="none">
+                <a:solidFill>
+                  <a:schemeClr val="dk2"/>
+                </a:solidFill>
+                <a:effectLst/>
+                <a:uFillTx/>
+                <a:latin typeface="Arial"/>
+                <a:ea typeface="Arial"/>
+              </a:rPr>
+              <a:t>&lt;número&gt;</a:t>
+            </a:fld>
+            <a:endParaRPr b="0" lang="es-MX" sz="1000" strike="noStrike" u="none">
+              <a:solidFill>
+                <a:srgbClr val="000000"/>
+              </a:solidFill>
+              <a:effectLst/>
+              <a:uFillTx/>
+              <a:latin typeface="Times New Roman"/>
+            </a:endParaRPr>
+          </a:p>
+        </p:txBody>
+      </p:sp>
+      <p:sp>
+        <p:nvSpPr>
+          <p:cNvPr id="11" name="PlaceHolder 2"/>
+          <p:cNvSpPr>
+            <a:spLocks noGrp="1"/>
+          </p:cNvSpPr>
+          <p:nvPr>
+            <p:ph type="title"/>
+          </p:nvPr>
+        </p:nvSpPr>
+        <p:spPr>
+          <a:xfrm>
+            <a:off x="457200" y="205200"/>
+            <a:ext cx="8228880" cy="858240"/>
+          </a:xfrm>
+          <a:prstGeom prst="rect">
+            <a:avLst/>
+          </a:prstGeom>
+          <a:noFill/>
+          <a:ln w="0">
+            <a:noFill/>
+          </a:ln>
+        </p:spPr>
+        <p:txBody>
+          <a:bodyPr lIns="0" rIns="0" tIns="0" bIns="0" anchor="ctr">
+            <a:noAutofit/>
+          </a:bodyPr>
+          <a:p>
+            <a:pPr indent="0">
+              <a:lnSpc>
+                <a:spcPct val="100000"/>
+              </a:lnSpc>
+              <a:buNone/>
+              <a:tabLst>
+                <a:tab algn="l" pos="0"/>
+              </a:tabLst>
+            </a:pPr>
+            <a:r>
+              <a:rPr b="0" lang="es-MX" sz="1400" strike="noStrike" u="none">
+                <a:solidFill>
+                  <a:srgbClr val="000000"/>
+                </a:solidFill>
+                <a:effectLst/>
+                <a:uFillTx/>
+                <a:latin typeface="Arial"/>
+              </a:rPr>
+              <a:t>Pulse para editar el formato del texto de título</a:t>
+            </a:r>
+            <a:endParaRPr b="0" lang="es-MX" sz="1400" strike="noStrike" u="none">
+              <a:solidFill>
+                <a:srgbClr val="000000"/>
+              </a:solidFill>
+              <a:effectLst/>
+              <a:uFillTx/>
+              <a:latin typeface="Arial"/>
+            </a:endParaRPr>
+          </a:p>
+        </p:txBody>
+      </p:sp>
+      <p:sp>
+        <p:nvSpPr>
+          <p:cNvPr id="12" name="PlaceHolder 3"/>
+          <p:cNvSpPr>
+            <a:spLocks noGrp="1"/>
+          </p:cNvSpPr>
+          <p:nvPr>
+            <p:ph type="body"/>
+          </p:nvPr>
+        </p:nvSpPr>
+        <p:spPr>
+          <a:xfrm>
+            <a:off x="457200" y="1203480"/>
+            <a:ext cx="8228880" cy="2982600"/>
+          </a:xfrm>
+          <a:prstGeom prst="rect">
+            <a:avLst/>
+          </a:prstGeom>
+          <a:noFill/>
+          <a:ln w="0">
+            <a:noFill/>
+          </a:ln>
+        </p:spPr>
+        <p:txBody>
+          <a:bodyPr lIns="0" rIns="0" tIns="0" bIns="0" anchor="t">
+            <a:normAutofit/>
+          </a:bodyPr>
+          <a:p>
+            <a:pPr marL="432000" indent="-324000">
+              <a:lnSpc>
+                <a:spcPct val="100000"/>
+              </a:lnSpc>
+              <a:spcBef>
+                <a:spcPts val="1417"/>
+              </a:spcBef>
+              <a:buClr>
+                <a:srgbClr val="000000"/>
+              </a:buClr>
+              <a:buSzPct val="45000"/>
+              <a:buFont typeface="Wingdings" charset="2"/>
+              <a:buChar char=""/>
+            </a:pPr>
+            <a:r>
+              <a:rPr b="0" lang="es-MX" sz="1400" strike="noStrike" u="none">
+                <a:solidFill>
+                  <a:srgbClr val="000000"/>
+                </a:solidFill>
+                <a:effectLst/>
+                <a:uFillTx/>
+                <a:latin typeface="Arial"/>
+              </a:rPr>
+              <a:t>Pulse para editar el formato de texto del esquema</a:t>
+            </a:r>
+            <a:endParaRPr b="0" lang="es-MX" sz="1400" strike="noStrike" u="none">
+              <a:solidFill>
+                <a:srgbClr val="000000"/>
+              </a:solidFill>
+              <a:effectLst/>
+              <a:uFillTx/>
+              <a:latin typeface="Arial"/>
+            </a:endParaRPr>
+          </a:p>
+          <a:p>
+            <a:pPr lvl="1" marL="864000" indent="-324000">
+              <a:lnSpc>
+                <a:spcPct val="100000"/>
+              </a:lnSpc>
+              <a:spcBef>
+                <a:spcPts val="1134"/>
+              </a:spcBef>
+              <a:buClr>
+                <a:srgbClr val="000000"/>
+              </a:buClr>
+              <a:buSzPct val="75000"/>
+              <a:buFont typeface="Symbol" charset="2"/>
+              <a:buChar char=""/>
+            </a:pPr>
+            <a:r>
+              <a:rPr b="0" lang="es-MX" sz="1400" strike="noStrike" u="none">
+                <a:solidFill>
+                  <a:srgbClr val="000000"/>
+                </a:solidFill>
+                <a:effectLst/>
+                <a:uFillTx/>
+                <a:latin typeface="Arial"/>
+              </a:rPr>
+              <a:t>Segundo nivel del esquema</a:t>
+            </a:r>
+            <a:endParaRPr b="0" lang="es-MX" sz="1400" strike="noStrike" u="none">
+              <a:solidFill>
+                <a:srgbClr val="000000"/>
+              </a:solidFill>
+              <a:effectLst/>
+              <a:uFillTx/>
+              <a:latin typeface="Arial"/>
+            </a:endParaRPr>
+          </a:p>
+          <a:p>
+            <a:pPr lvl="2" marL="1296000" indent="-288000">
+              <a:lnSpc>
+                <a:spcPct val="100000"/>
+              </a:lnSpc>
+              <a:spcBef>
+                <a:spcPts val="850"/>
+              </a:spcBef>
+              <a:buClr>
+                <a:srgbClr val="000000"/>
+              </a:buClr>
+              <a:buSzPct val="45000"/>
+              <a:buFont typeface="Wingdings" charset="2"/>
+              <a:buChar char=""/>
+            </a:pPr>
+            <a:r>
+              <a:rPr b="0" lang="es-MX" sz="1400" strike="noStrike" u="none">
+                <a:solidFill>
+                  <a:srgbClr val="000000"/>
+                </a:solidFill>
+                <a:effectLst/>
+                <a:uFillTx/>
+                <a:latin typeface="Arial"/>
+              </a:rPr>
+              <a:t>Tercer nivel del esquema</a:t>
+            </a:r>
+            <a:endParaRPr b="0" lang="es-MX" sz="1400" strike="noStrike" u="none">
+              <a:solidFill>
+                <a:srgbClr val="000000"/>
+              </a:solidFill>
+              <a:effectLst/>
+              <a:uFillTx/>
+              <a:latin typeface="Arial"/>
+            </a:endParaRPr>
+          </a:p>
+          <a:p>
+            <a:pPr lvl="3" marL="1728000" indent="-216000">
+              <a:lnSpc>
+                <a:spcPct val="100000"/>
+              </a:lnSpc>
+              <a:spcBef>
+                <a:spcPts val="567"/>
+              </a:spcBef>
+              <a:buClr>
+                <a:srgbClr val="000000"/>
+              </a:buClr>
+              <a:buSzPct val="75000"/>
+              <a:buFont typeface="Symbol" charset="2"/>
+              <a:buChar char=""/>
+            </a:pPr>
+            <a:r>
+              <a:rPr b="0" lang="es-MX" sz="1400" strike="noStrike" u="none">
+                <a:solidFill>
+                  <a:srgbClr val="000000"/>
+                </a:solidFill>
+                <a:effectLst/>
+                <a:uFillTx/>
+                <a:latin typeface="Arial"/>
+              </a:rPr>
+              <a:t>Cuarto nivel del esquema</a:t>
+            </a:r>
+            <a:endParaRPr b="0" lang="es-MX" sz="1400" strike="noStrike" u="none">
+              <a:solidFill>
+                <a:srgbClr val="000000"/>
+              </a:solidFill>
+              <a:effectLst/>
+              <a:uFillTx/>
+              <a:latin typeface="Arial"/>
+            </a:endParaRPr>
+          </a:p>
+          <a:p>
+            <a:pPr lvl="4" marL="2160000" indent="-216000">
+              <a:lnSpc>
+                <a:spcPct val="100000"/>
+              </a:lnSpc>
+              <a:spcBef>
+                <a:spcPts val="283"/>
+              </a:spcBef>
+              <a:buClr>
+                <a:srgbClr val="000000"/>
+              </a:buClr>
+              <a:buSzPct val="45000"/>
+              <a:buFont typeface="Wingdings" charset="2"/>
+              <a:buChar char=""/>
+            </a:pPr>
+            <a:r>
+              <a:rPr b="0" lang="es-MX" sz="2000" strike="noStrike" u="none">
+                <a:solidFill>
+                  <a:srgbClr val="000000"/>
+                </a:solidFill>
+                <a:effectLst/>
+                <a:uFillTx/>
+                <a:latin typeface="Arial"/>
+              </a:rPr>
+              <a:t>Quinto nivel del esquema</a:t>
+            </a:r>
+            <a:endParaRPr b="0" lang="es-MX" sz="2000" strike="noStrike" u="none">
+              <a:solidFill>
+                <a:srgbClr val="000000"/>
+              </a:solidFill>
+              <a:effectLst/>
+              <a:uFillTx/>
+              <a:latin typeface="Arial"/>
+            </a:endParaRPr>
+          </a:p>
+          <a:p>
+            <a:pPr lvl="5" marL="2592000" indent="-216000">
+              <a:lnSpc>
+                <a:spcPct val="100000"/>
+              </a:lnSpc>
+              <a:spcBef>
+                <a:spcPts val="283"/>
+              </a:spcBef>
+              <a:buClr>
+                <a:srgbClr val="000000"/>
+              </a:buClr>
+              <a:buSzPct val="45000"/>
+              <a:buFont typeface="Wingdings" charset="2"/>
+              <a:buChar char=""/>
+            </a:pPr>
+            <a:r>
+              <a:rPr b="0" lang="es-MX" sz="2000" strike="noStrike" u="none">
+                <a:solidFill>
+                  <a:srgbClr val="000000"/>
+                </a:solidFill>
+                <a:effectLst/>
+                <a:uFillTx/>
+                <a:latin typeface="Arial"/>
+              </a:rPr>
+              <a:t>Sexto nivel del esquema</a:t>
+            </a:r>
+            <a:endParaRPr b="0" lang="es-MX" sz="2000" strike="noStrike" u="none">
+              <a:solidFill>
+                <a:srgbClr val="000000"/>
+              </a:solidFill>
+              <a:effectLst/>
+              <a:uFillTx/>
+              <a:latin typeface="Arial"/>
+            </a:endParaRPr>
+          </a:p>
+          <a:p>
+            <a:pPr lvl="6" marL="3024000" indent="-216000">
+              <a:lnSpc>
+                <a:spcPct val="100000"/>
+              </a:lnSpc>
+              <a:spcBef>
+                <a:spcPts val="283"/>
+              </a:spcBef>
+              <a:buClr>
+                <a:srgbClr val="000000"/>
+              </a:buClr>
+              <a:buSzPct val="45000"/>
+              <a:buFont typeface="Wingdings" charset="2"/>
+              <a:buChar char=""/>
+            </a:pPr>
+            <a:r>
+              <a:rPr b="0" lang="es-MX" sz="2000" strike="noStrike" u="none">
+                <a:solidFill>
+                  <a:srgbClr val="000000"/>
+                </a:solidFill>
+                <a:effectLst/>
+                <a:uFillTx/>
+                <a:latin typeface="Arial"/>
+              </a:rPr>
+              <a:t>Séptimo nivel del esquema</a:t>
+            </a:r>
+            <a:endParaRPr b="0" lang="es-MX" sz="2000" strike="noStrike" u="none">
+              <a:solidFill>
+                <a:srgbClr val="000000"/>
+              </a:solidFill>
+              <a:effectLst/>
+              <a:uFillTx/>
+              <a:latin typeface="Arial"/>
+            </a:endParaRPr>
+          </a:p>
+        </p:txBody>
+      </p:sp>
+    </p:spTree>
+  </p:cSld>
+</p:sldLayout>
+</file>
+
+<file path=ppt/slideLayouts/slideLayout8.xml><?xml version="1.0" encoding="utf-8"?>
 <p:sldLayout xmlns:a="http://schemas.openxmlformats.org/drawingml/2006/main" xmlns:p="http://schemas.openxmlformats.org/presentationml/2006/main" xmlns:r="http://schemas.openxmlformats.org/officeDocument/2006/relationships" xmlns:p14="http://schemas.microsoft.com/office/powerpoint/2010/main" xmlns:p15="http://schemas.microsoft.com/office/powerpoint/2012/main" xmlns:mc="http://schemas.openxmlformats.org/markup-compatibility/2006" type="blank" preserve="1">
   <p:cSld name="DEFAULT">
     <p:bg>
@@ -1296,7 +1785,7 @@
 </p:sldLayout>
 </file>
 
-<file path=ppt/slideLayouts/slideLayout5.xml><?xml version="1.0" encoding="utf-8"?>
+<file path=ppt/slideLayouts/slideLayout9.xml><?xml version="1.0" encoding="utf-8"?>
 <p:sldLayout xmlns:a="http://schemas.openxmlformats.org/drawingml/2006/main" xmlns:p="http://schemas.openxmlformats.org/presentationml/2006/main" xmlns:r="http://schemas.openxmlformats.org/officeDocument/2006/relationships" xmlns:p14="http://schemas.microsoft.com/office/powerpoint/2010/main" xmlns:p15="http://schemas.microsoft.com/office/powerpoint/2012/main" xmlns:mc="http://schemas.openxmlformats.org/markup-compatibility/2006" type="blank" preserve="1">
   <p:cSld name="SECTION_HEADER">
     <p:bg>
@@ -1320,442 +1809,6 @@
           <a:chExt cx="0" cy="0"/>
         </a:xfrm>
       </p:grpSpPr>
-    </p:spTree>
-  </p:cSld>
-</p:sldLayout>
-</file>
-
-<file path=ppt/slideLayouts/slideLayout6.xml><?xml version="1.0" encoding="utf-8"?>
-<p:sldLayout xmlns:a="http://schemas.openxmlformats.org/drawingml/2006/main" xmlns:p="http://schemas.openxmlformats.org/presentationml/2006/main" xmlns:r="http://schemas.openxmlformats.org/officeDocument/2006/relationships" xmlns:p14="http://schemas.microsoft.com/office/powerpoint/2010/main" xmlns:p15="http://schemas.microsoft.com/office/powerpoint/2012/main" xmlns:mc="http://schemas.openxmlformats.org/markup-compatibility/2006" type="tx" preserve="1">
-  <p:cSld name="TITLE_AND_BODY">
-    <p:bg>
-      <p:bgPr>
-        <a:solidFill>
-          <a:schemeClr val="lt1"/>
-        </a:solidFill>
-      </p:bgPr>
-    </p:bg>
-    <p:spTree>
-      <p:nvGrpSpPr>
-        <p:cNvPr id="1" name=""/>
-        <p:cNvGrpSpPr/>
-        <p:nvPr/>
-      </p:nvGrpSpPr>
-      <p:grpSpPr>
-        <a:xfrm>
-          <a:off x="0" y="0"/>
-          <a:ext cx="0" cy="0"/>
-          <a:chOff x="0" y="0"/>
-          <a:chExt cx="0" cy="0"/>
-        </a:xfrm>
-      </p:grpSpPr>
-      <p:sp>
-        <p:nvSpPr>
-          <p:cNvPr id="9" name="PlaceHolder 1"/>
-          <p:cNvSpPr>
-            <a:spLocks noGrp="1"/>
-          </p:cNvSpPr>
-          <p:nvPr>
-            <p:ph type="sldNum" idx="4"/>
-          </p:nvPr>
-        </p:nvSpPr>
-        <p:spPr>
-          <a:xfrm>
-            <a:off x="8472600" y="4663080"/>
-            <a:ext cx="548280" cy="393120"/>
-          </a:xfrm>
-          <a:prstGeom prst="rect">
-            <a:avLst/>
-          </a:prstGeom>
-          <a:noFill/>
-          <a:ln w="0">
-            <a:noFill/>
-          </a:ln>
-        </p:spPr>
-        <p:txBody>
-          <a:bodyPr lIns="91440" rIns="91440" tIns="91440" bIns="91440" anchor="ctr">
-            <a:normAutofit/>
-          </a:bodyPr>
-          <a:lstStyle>
-            <a:lvl1pPr indent="0" algn="r">
-              <a:lnSpc>
-                <a:spcPct val="100000"/>
-              </a:lnSpc>
-              <a:buNone/>
-              <a:tabLst>
-                <a:tab algn="l" pos="0"/>
-              </a:tabLst>
-              <a:defRPr b="0" lang="en" sz="1000" strike="noStrike" u="none">
-                <a:solidFill>
-                  <a:schemeClr val="dk2"/>
-                </a:solidFill>
-                <a:effectLst/>
-                <a:uFillTx/>
-                <a:latin typeface="Arial"/>
-                <a:ea typeface="Arial"/>
-              </a:defRPr>
-            </a:lvl1pPr>
-          </a:lstStyle>
-          <a:p>
-            <a:pPr indent="0" algn="r">
-              <a:lnSpc>
-                <a:spcPct val="100000"/>
-              </a:lnSpc>
-              <a:buNone/>
-              <a:tabLst>
-                <a:tab algn="l" pos="0"/>
-              </a:tabLst>
-            </a:pPr>
-            <a:fld id="{EE40049F-0427-4FF4-8CF2-4230B23400D3}" type="slidenum">
-              <a:rPr b="0" lang="en" sz="1000" strike="noStrike" u="none">
-                <a:solidFill>
-                  <a:schemeClr val="dk2"/>
-                </a:solidFill>
-                <a:effectLst/>
-                <a:uFillTx/>
-                <a:latin typeface="Arial"/>
-                <a:ea typeface="Arial"/>
-              </a:rPr>
-              <a:t>&lt;número&gt;</a:t>
-            </a:fld>
-            <a:endParaRPr b="0" lang="es-MX" sz="1000" strike="noStrike" u="none">
-              <a:solidFill>
-                <a:srgbClr val="000000"/>
-              </a:solidFill>
-              <a:effectLst/>
-              <a:uFillTx/>
-              <a:latin typeface="Times New Roman"/>
-            </a:endParaRPr>
-          </a:p>
-        </p:txBody>
-      </p:sp>
-    </p:spTree>
-  </p:cSld>
-</p:sldLayout>
-</file>
-
-<file path=ppt/slideLayouts/slideLayout7.xml><?xml version="1.0" encoding="utf-8"?>
-<p:sldLayout xmlns:a="http://schemas.openxmlformats.org/drawingml/2006/main" xmlns:p="http://schemas.openxmlformats.org/presentationml/2006/main" xmlns:r="http://schemas.openxmlformats.org/officeDocument/2006/relationships" xmlns:p14="http://schemas.microsoft.com/office/powerpoint/2010/main" xmlns:p15="http://schemas.microsoft.com/office/powerpoint/2012/main" xmlns:mc="http://schemas.openxmlformats.org/markup-compatibility/2006" type="twoObj" preserve="1">
-  <p:cSld name="TITLE_AND_TWO_COLUMNS">
-    <p:bg>
-      <p:bgPr>
-        <a:solidFill>
-          <a:schemeClr val="lt1"/>
-        </a:solidFill>
-      </p:bgPr>
-    </p:bg>
-    <p:spTree>
-      <p:nvGrpSpPr>
-        <p:cNvPr id="1" name=""/>
-        <p:cNvGrpSpPr/>
-        <p:nvPr/>
-      </p:nvGrpSpPr>
-      <p:grpSpPr>
-        <a:xfrm>
-          <a:off x="0" y="0"/>
-          <a:ext cx="0" cy="0"/>
-          <a:chOff x="0" y="0"/>
-          <a:chExt cx="0" cy="0"/>
-        </a:xfrm>
-      </p:grpSpPr>
-      <p:sp>
-        <p:nvSpPr>
-          <p:cNvPr id="10" name="PlaceHolder 1"/>
-          <p:cNvSpPr>
-            <a:spLocks noGrp="1"/>
-          </p:cNvSpPr>
-          <p:nvPr>
-            <p:ph type="sldNum" idx="5"/>
-          </p:nvPr>
-        </p:nvSpPr>
-        <p:spPr>
-          <a:xfrm>
-            <a:off x="8472600" y="4663080"/>
-            <a:ext cx="548280" cy="393120"/>
-          </a:xfrm>
-          <a:prstGeom prst="rect">
-            <a:avLst/>
-          </a:prstGeom>
-          <a:noFill/>
-          <a:ln w="0">
-            <a:noFill/>
-          </a:ln>
-        </p:spPr>
-        <p:txBody>
-          <a:bodyPr lIns="91440" rIns="91440" tIns="91440" bIns="91440" anchor="ctr">
-            <a:normAutofit/>
-          </a:bodyPr>
-          <a:lstStyle>
-            <a:lvl1pPr indent="0" algn="r">
-              <a:lnSpc>
-                <a:spcPct val="100000"/>
-              </a:lnSpc>
-              <a:buNone/>
-              <a:tabLst>
-                <a:tab algn="l" pos="0"/>
-              </a:tabLst>
-              <a:defRPr b="0" lang="en" sz="1000" strike="noStrike" u="none">
-                <a:solidFill>
-                  <a:schemeClr val="dk2"/>
-                </a:solidFill>
-                <a:effectLst/>
-                <a:uFillTx/>
-                <a:latin typeface="Arial"/>
-                <a:ea typeface="Arial"/>
-              </a:defRPr>
-            </a:lvl1pPr>
-          </a:lstStyle>
-          <a:p>
-            <a:pPr indent="0" algn="r">
-              <a:lnSpc>
-                <a:spcPct val="100000"/>
-              </a:lnSpc>
-              <a:buNone/>
-              <a:tabLst>
-                <a:tab algn="l" pos="0"/>
-              </a:tabLst>
-            </a:pPr>
-            <a:fld id="{A361CDFA-770F-42F4-9BA3-88379FE19A96}" type="slidenum">
-              <a:rPr b="0" lang="en" sz="1000" strike="noStrike" u="none">
-                <a:solidFill>
-                  <a:schemeClr val="dk2"/>
-                </a:solidFill>
-                <a:effectLst/>
-                <a:uFillTx/>
-                <a:latin typeface="Arial"/>
-                <a:ea typeface="Arial"/>
-              </a:rPr>
-              <a:t>&lt;número&gt;</a:t>
-            </a:fld>
-            <a:endParaRPr b="0" lang="es-MX" sz="1000" strike="noStrike" u="none">
-              <a:solidFill>
-                <a:srgbClr val="000000"/>
-              </a:solidFill>
-              <a:effectLst/>
-              <a:uFillTx/>
-              <a:latin typeface="Times New Roman"/>
-            </a:endParaRPr>
-          </a:p>
-        </p:txBody>
-      </p:sp>
-    </p:spTree>
-  </p:cSld>
-</p:sldLayout>
-</file>
-
-<file path=ppt/slideLayouts/slideLayout8.xml><?xml version="1.0" encoding="utf-8"?>
-<p:sldLayout xmlns:a="http://schemas.openxmlformats.org/drawingml/2006/main" xmlns:p="http://schemas.openxmlformats.org/presentationml/2006/main" xmlns:r="http://schemas.openxmlformats.org/officeDocument/2006/relationships" xmlns:p14="http://schemas.microsoft.com/office/powerpoint/2010/main" xmlns:p15="http://schemas.microsoft.com/office/powerpoint/2012/main" xmlns:mc="http://schemas.openxmlformats.org/markup-compatibility/2006" type="titleOnly" preserve="1">
-  <p:cSld name="TITLE_ONLY">
-    <p:bg>
-      <p:bgPr>
-        <a:solidFill>
-          <a:schemeClr val="lt1"/>
-        </a:solidFill>
-      </p:bgPr>
-    </p:bg>
-    <p:spTree>
-      <p:nvGrpSpPr>
-        <p:cNvPr id="1" name=""/>
-        <p:cNvGrpSpPr/>
-        <p:nvPr/>
-      </p:nvGrpSpPr>
-      <p:grpSpPr>
-        <a:xfrm>
-          <a:off x="0" y="0"/>
-          <a:ext cx="0" cy="0"/>
-          <a:chOff x="0" y="0"/>
-          <a:chExt cx="0" cy="0"/>
-        </a:xfrm>
-      </p:grpSpPr>
-      <p:sp>
-        <p:nvSpPr>
-          <p:cNvPr id="11" name="PlaceHolder 1"/>
-          <p:cNvSpPr>
-            <a:spLocks noGrp="1"/>
-          </p:cNvSpPr>
-          <p:nvPr>
-            <p:ph type="sldNum" idx="6"/>
-          </p:nvPr>
-        </p:nvSpPr>
-        <p:spPr>
-          <a:xfrm>
-            <a:off x="8472600" y="4663080"/>
-            <a:ext cx="548280" cy="393120"/>
-          </a:xfrm>
-          <a:prstGeom prst="rect">
-            <a:avLst/>
-          </a:prstGeom>
-          <a:noFill/>
-          <a:ln w="0">
-            <a:noFill/>
-          </a:ln>
-        </p:spPr>
-        <p:txBody>
-          <a:bodyPr lIns="91440" rIns="91440" tIns="91440" bIns="91440" anchor="ctr">
-            <a:normAutofit/>
-          </a:bodyPr>
-          <a:lstStyle>
-            <a:lvl1pPr indent="0" algn="r">
-              <a:lnSpc>
-                <a:spcPct val="100000"/>
-              </a:lnSpc>
-              <a:buNone/>
-              <a:tabLst>
-                <a:tab algn="l" pos="0"/>
-              </a:tabLst>
-              <a:defRPr b="0" lang="en" sz="1000" strike="noStrike" u="none">
-                <a:solidFill>
-                  <a:schemeClr val="dk2"/>
-                </a:solidFill>
-                <a:effectLst/>
-                <a:uFillTx/>
-                <a:latin typeface="Arial"/>
-                <a:ea typeface="Arial"/>
-              </a:defRPr>
-            </a:lvl1pPr>
-          </a:lstStyle>
-          <a:p>
-            <a:pPr indent="0" algn="r">
-              <a:lnSpc>
-                <a:spcPct val="100000"/>
-              </a:lnSpc>
-              <a:buNone/>
-              <a:tabLst>
-                <a:tab algn="l" pos="0"/>
-              </a:tabLst>
-            </a:pPr>
-            <a:fld id="{7BEDDEA9-890E-4327-9D0B-5267535B7216}" type="slidenum">
-              <a:rPr b="0" lang="en" sz="1000" strike="noStrike" u="none">
-                <a:solidFill>
-                  <a:schemeClr val="dk2"/>
-                </a:solidFill>
-                <a:effectLst/>
-                <a:uFillTx/>
-                <a:latin typeface="Arial"/>
-                <a:ea typeface="Arial"/>
-              </a:rPr>
-              <a:t>&lt;número&gt;</a:t>
-            </a:fld>
-            <a:endParaRPr b="0" lang="es-MX" sz="1000" strike="noStrike" u="none">
-              <a:solidFill>
-                <a:srgbClr val="000000"/>
-              </a:solidFill>
-              <a:effectLst/>
-              <a:uFillTx/>
-              <a:latin typeface="Times New Roman"/>
-            </a:endParaRPr>
-          </a:p>
-        </p:txBody>
-      </p:sp>
-    </p:spTree>
-  </p:cSld>
-</p:sldLayout>
-</file>
-
-<file path=ppt/slideLayouts/slideLayout9.xml><?xml version="1.0" encoding="utf-8"?>
-<p:sldLayout xmlns:a="http://schemas.openxmlformats.org/drawingml/2006/main" xmlns:p="http://schemas.openxmlformats.org/presentationml/2006/main" xmlns:r="http://schemas.openxmlformats.org/officeDocument/2006/relationships" xmlns:p14="http://schemas.microsoft.com/office/powerpoint/2010/main" xmlns:p15="http://schemas.microsoft.com/office/powerpoint/2012/main" xmlns:mc="http://schemas.openxmlformats.org/markup-compatibility/2006" type="blank" preserve="1">
-  <p:cSld name="ONE_COLUMN_TEXT">
-    <p:bg>
-      <p:bgPr>
-        <a:solidFill>
-          <a:schemeClr val="lt1"/>
-        </a:solidFill>
-      </p:bgPr>
-    </p:bg>
-    <p:spTree>
-      <p:nvGrpSpPr>
-        <p:cNvPr id="1" name=""/>
-        <p:cNvGrpSpPr/>
-        <p:nvPr/>
-      </p:nvGrpSpPr>
-      <p:grpSpPr>
-        <a:xfrm>
-          <a:off x="0" y="0"/>
-          <a:ext cx="0" cy="0"/>
-          <a:chOff x="0" y="0"/>
-          <a:chExt cx="0" cy="0"/>
-        </a:xfrm>
-      </p:grpSpPr>
-      <p:sp>
-        <p:nvSpPr>
-          <p:cNvPr id="12" name="PlaceHolder 1"/>
-          <p:cNvSpPr>
-            <a:spLocks noGrp="1"/>
-          </p:cNvSpPr>
-          <p:nvPr>
-            <p:ph type="sldNum" idx="7"/>
-          </p:nvPr>
-        </p:nvSpPr>
-        <p:spPr>
-          <a:xfrm>
-            <a:off x="8472600" y="4663080"/>
-            <a:ext cx="548280" cy="393120"/>
-          </a:xfrm>
-          <a:prstGeom prst="rect">
-            <a:avLst/>
-          </a:prstGeom>
-          <a:noFill/>
-          <a:ln w="0">
-            <a:noFill/>
-          </a:ln>
-        </p:spPr>
-        <p:txBody>
-          <a:bodyPr lIns="91440" rIns="91440" tIns="91440" bIns="91440" anchor="ctr">
-            <a:normAutofit/>
-          </a:bodyPr>
-          <a:lstStyle>
-            <a:lvl1pPr indent="0" algn="r">
-              <a:lnSpc>
-                <a:spcPct val="100000"/>
-              </a:lnSpc>
-              <a:buNone/>
-              <a:tabLst>
-                <a:tab algn="l" pos="0"/>
-              </a:tabLst>
-              <a:defRPr b="0" lang="en" sz="1000" strike="noStrike" u="none">
-                <a:solidFill>
-                  <a:schemeClr val="dk2"/>
-                </a:solidFill>
-                <a:effectLst/>
-                <a:uFillTx/>
-                <a:latin typeface="Arial"/>
-                <a:ea typeface="Arial"/>
-              </a:defRPr>
-            </a:lvl1pPr>
-          </a:lstStyle>
-          <a:p>
-            <a:pPr indent="0" algn="r">
-              <a:lnSpc>
-                <a:spcPct val="100000"/>
-              </a:lnSpc>
-              <a:buNone/>
-              <a:tabLst>
-                <a:tab algn="l" pos="0"/>
-              </a:tabLst>
-            </a:pPr>
-            <a:fld id="{1CF82003-4B5F-4FCF-AA55-116003D172B8}" type="slidenum">
-              <a:rPr b="0" lang="en" sz="1000" strike="noStrike" u="none">
-                <a:solidFill>
-                  <a:schemeClr val="dk2"/>
-                </a:solidFill>
-                <a:effectLst/>
-                <a:uFillTx/>
-                <a:latin typeface="Arial"/>
-                <a:ea typeface="Arial"/>
-              </a:rPr>
-              <a:t>&lt;número&gt;</a:t>
-            </a:fld>
-            <a:endParaRPr b="0" lang="es-MX" sz="1000" strike="noStrike" u="none">
-              <a:solidFill>
-                <a:srgbClr val="000000"/>
-              </a:solidFill>
-              <a:effectLst/>
-              <a:uFillTx/>
-              <a:latin typeface="Times New Roman"/>
-            </a:endParaRPr>
-          </a:p>
-        </p:txBody>
-      </p:sp>
     </p:spTree>
   </p:cSld>
 </p:sldLayout>
@@ -1835,7 +1888,7 @@
         <p:spPr>
           <a:xfrm>
             <a:off x="64080" y="638280"/>
-            <a:ext cx="8520120" cy="1359360"/>
+            <a:ext cx="8519760" cy="1359720"/>
           </a:xfrm>
           <a:prstGeom prst="rect">
             <a:avLst/>
@@ -1929,7 +1982,7 @@
         <p:spPr>
           <a:xfrm>
             <a:off x="228600" y="228600"/>
-            <a:ext cx="866520" cy="194040"/>
+            <a:ext cx="866160" cy="193680"/>
           </a:xfrm>
           <a:prstGeom prst="rect">
             <a:avLst/>
@@ -1952,8 +2005,8 @@
         </p:nvSpPr>
         <p:spPr>
           <a:xfrm>
-            <a:off x="152280" y="4587120"/>
-            <a:ext cx="8686440" cy="396720"/>
+            <a:off x="152280" y="4556520"/>
+            <a:ext cx="8686080" cy="457560"/>
           </a:xfrm>
           <a:prstGeom prst="rect">
             <a:avLst/>
@@ -2049,7 +2102,7 @@
         <p:spPr>
           <a:xfrm>
             <a:off x="228600" y="228600"/>
-            <a:ext cx="866520" cy="194040"/>
+            <a:ext cx="866160" cy="193680"/>
           </a:xfrm>
           <a:prstGeom prst="rect">
             <a:avLst/>
@@ -2072,8 +2125,8 @@
         </p:nvSpPr>
         <p:spPr>
           <a:xfrm>
-            <a:off x="96840" y="424800"/>
-            <a:ext cx="8520120" cy="800640"/>
+            <a:off x="21240" y="219240"/>
+            <a:ext cx="8519760" cy="801000"/>
           </a:xfrm>
           <a:prstGeom prst="rect">
             <a:avLst/>
@@ -2123,13 +2176,13 @@
       <p:sp>
         <p:nvSpPr>
           <p:cNvPr id="21" name=""/>
-          <p:cNvSpPr txBox="1"/>
+          <p:cNvSpPr/>
           <p:nvPr/>
         </p:nvSpPr>
         <p:spPr>
           <a:xfrm>
-            <a:off x="540000" y="1224000"/>
-            <a:ext cx="7920000" cy="3929760"/>
+            <a:off x="180000" y="1080000"/>
+            <a:ext cx="8279640" cy="4204440"/>
           </a:xfrm>
           <a:prstGeom prst="rect">
             <a:avLst/>
@@ -2139,12 +2192,21 @@
             <a:noFill/>
           </a:ln>
         </p:spPr>
+        <p:style>
+          <a:lnRef idx="0"/>
+          <a:fillRef idx="0"/>
+          <a:effectRef idx="0"/>
+          <a:fontRef idx="minor"/>
+        </p:style>
         <p:txBody>
           <a:bodyPr lIns="90000" rIns="90000" tIns="45000" bIns="45000" anchor="t">
             <a:spAutoFit/>
           </a:bodyPr>
           <a:p>
             <a:pPr marL="216000" indent="-216000">
+              <a:lnSpc>
+                <a:spcPct val="100000"/>
+              </a:lnSpc>
               <a:buClr>
                 <a:srgbClr val="000000"/>
               </a:buClr>
@@ -2206,6 +2268,11 @@
             </a:endParaRPr>
           </a:p>
           <a:p>
+            <a:pPr>
+              <a:lnSpc>
+                <a:spcPct val="100000"/>
+              </a:lnSpc>
+            </a:pPr>
             <a:r>
               <a:rPr b="0" lang="es-MX" sz="1800" strike="noStrike" u="none">
                 <a:solidFill>
@@ -2227,6 +2294,11 @@
             </a:endParaRPr>
           </a:p>
           <a:p>
+            <a:pPr>
+              <a:lnSpc>
+                <a:spcPct val="100000"/>
+              </a:lnSpc>
+            </a:pPr>
             <a:endParaRPr b="0" lang="es-MX" sz="1800" strike="noStrike" u="none">
               <a:solidFill>
                 <a:srgbClr val="000000"/>
@@ -2238,6 +2310,9 @@
           </a:p>
           <a:p>
             <a:pPr marL="216000" indent="-216000">
+              <a:lnSpc>
+                <a:spcPct val="100000"/>
+              </a:lnSpc>
               <a:buClr>
                 <a:srgbClr val="000000"/>
               </a:buClr>
@@ -2299,6 +2374,11 @@
             </a:endParaRPr>
           </a:p>
           <a:p>
+            <a:pPr>
+              <a:lnSpc>
+                <a:spcPct val="100000"/>
+              </a:lnSpc>
+            </a:pPr>
             <a:r>
               <a:rPr b="0" lang="es-MX" sz="1800" strike="noStrike" u="none">
                 <a:solidFill>
@@ -2320,6 +2400,11 @@
             </a:endParaRPr>
           </a:p>
           <a:p>
+            <a:pPr>
+              <a:lnSpc>
+                <a:spcPct val="100000"/>
+              </a:lnSpc>
+            </a:pPr>
             <a:endParaRPr b="0" lang="es-MX" sz="1800" strike="noStrike" u="none">
               <a:solidFill>
                 <a:srgbClr val="000000"/>
@@ -2331,6 +2416,9 @@
           </a:p>
           <a:p>
             <a:pPr marL="216000" indent="-216000">
+              <a:lnSpc>
+                <a:spcPct val="100000"/>
+              </a:lnSpc>
               <a:buClr>
                 <a:srgbClr val="000000"/>
               </a:buClr>
@@ -2348,18 +2436,31 @@
                 <a:latin typeface="Arial"/>
                 <a:ea typeface="Microsoft YaHei"/>
               </a:rPr>
-              <a:t>Code Challenge 📊</a:t>
-            </a:r>
-            <a:r>
-              <a:rPr b="1" lang="es-MX" sz="1800" strike="noStrike" u="none">
+              <a:t>Code Challenge 📊🚀</a:t>
+            </a:r>
+            <a:r>
+              <a:rPr b="0" lang="es-MX" sz="1800" strike="noStrike" u="none">
                 <a:solidFill>
                   <a:srgbClr val="000000"/>
                 </a:solidFill>
                 <a:effectLst/>
                 <a:uFillTx/>
                 <a:latin typeface="Arial"/>
-              </a:rPr>
-              <a:t>🚀</a:t>
+                <a:ea typeface="Microsoft YaHei"/>
+              </a:rPr>
+              <a:t> (</a:t>
+            </a:r>
+            <a:r>
+              <a:rPr b="0" i="1" lang="es-MX" sz="1800" strike="noStrike" u="none">
+                <a:solidFill>
+                  <a:srgbClr val="000000"/>
+                </a:solidFill>
+                <a:effectLst/>
+                <a:uFillTx/>
+                <a:latin typeface="Arial"/>
+                <a:ea typeface="Microsoft YaHei"/>
+              </a:rPr>
+              <a:t>75 min</a:t>
             </a:r>
             <a:r>
               <a:rPr b="0" lang="es-MX" sz="1800" strike="noStrike" u="none">
@@ -2369,30 +2470,36 @@
                 <a:effectLst/>
                 <a:uFillTx/>
                 <a:latin typeface="Arial"/>
-              </a:rPr>
-              <a:t> (</a:t>
-            </a:r>
-            <a:r>
-              <a:rPr b="0" i="1" lang="es-MX" sz="1800" strike="noStrike" u="none">
+                <a:ea typeface="Microsoft YaHei"/>
+              </a:rPr>
+              <a:t>)</a:t>
+            </a:r>
+            <a:endParaRPr b="0" lang="es-MX" sz="1800" strike="noStrike" u="none">
+              <a:solidFill>
+                <a:srgbClr val="000000"/>
+              </a:solidFill>
+              <a:effectLst/>
+              <a:uFillTx/>
+              <a:latin typeface="Arial"/>
+            </a:endParaRPr>
+          </a:p>
+          <a:p>
+            <a:pPr>
+              <a:lnSpc>
+                <a:spcPct val="100000"/>
+              </a:lnSpc>
+            </a:pPr>
+            <a:r>
+              <a:rPr b="0" lang="es-MX" sz="1800" strike="noStrike" u="none">
                 <a:solidFill>
                   <a:srgbClr val="000000"/>
                 </a:solidFill>
                 <a:effectLst/>
                 <a:uFillTx/>
                 <a:latin typeface="Arial"/>
-              </a:rPr>
-              <a:t>75 min</a:t>
-            </a:r>
-            <a:r>
-              <a:rPr b="0" lang="es-MX" sz="1800" strike="noStrike" u="none">
-                <a:solidFill>
-                  <a:srgbClr val="000000"/>
-                </a:solidFill>
-                <a:effectLst/>
-                <a:uFillTx/>
-                <a:latin typeface="Arial"/>
-              </a:rPr>
-              <a:t>)</a:t>
+                <a:ea typeface="Microsoft YaHei"/>
+              </a:rPr>
+              <a:t>Resolveremos un reto práctico para integrar habilidades🌐 📈.</a:t>
             </a:r>
             <a:endParaRPr b="0" lang="es-MX" sz="1800" strike="noStrike" u="none">
               <a:solidFill>
@@ -2404,39 +2511,11 @@
             </a:endParaRPr>
           </a:p>
           <a:p>
-            <a:r>
-              <a:rPr b="0" lang="es-MX" sz="1800" strike="noStrike" u="none">
-                <a:solidFill>
-                  <a:srgbClr val="000000"/>
-                </a:solidFill>
-                <a:effectLst/>
-                <a:uFillTx/>
-                <a:latin typeface="Arial"/>
-                <a:ea typeface="Microsoft YaHei"/>
-              </a:rPr>
-              <a:t>Resolveremos un reto práctico para integrar habilidades🌐 </a:t>
-            </a:r>
-            <a:r>
-              <a:rPr b="0" lang="es-MX" sz="1800" strike="noStrike" u="none">
-                <a:solidFill>
-                  <a:srgbClr val="000000"/>
-                </a:solidFill>
-                <a:effectLst/>
-                <a:uFillTx/>
-                <a:latin typeface="Arial"/>
-              </a:rPr>
-              <a:t>📈.</a:t>
-            </a:r>
-            <a:endParaRPr b="0" lang="es-MX" sz="1800" strike="noStrike" u="none">
-              <a:solidFill>
-                <a:srgbClr val="000000"/>
-              </a:solidFill>
-              <a:effectLst/>
-              <a:uFillTx/>
-              <a:latin typeface="Arial"/>
-            </a:endParaRPr>
-          </a:p>
-          <a:p>
+            <a:pPr>
+              <a:lnSpc>
+                <a:spcPct val="100000"/>
+              </a:lnSpc>
+            </a:pPr>
             <a:endParaRPr b="0" lang="es-MX" sz="1800" strike="noStrike" u="none">
               <a:solidFill>
                 <a:srgbClr val="000000"/>
@@ -2466,6 +2545,7 @@
                 <a:effectLst/>
                 <a:uFillTx/>
                 <a:latin typeface="Arial"/>
+                <a:ea typeface="Microsoft YaHei"/>
               </a:rPr>
               <a:t>Cierre</a:t>
             </a:r>
@@ -2477,6 +2557,7 @@
                 <a:effectLst/>
                 <a:uFillTx/>
                 <a:latin typeface="Arial"/>
+                <a:ea typeface="Microsoft YaHei"/>
               </a:rPr>
               <a:t> (</a:t>
             </a:r>
@@ -2488,6 +2569,7 @@
                 <a:effectLst/>
                 <a:uFillTx/>
                 <a:latin typeface="Arial"/>
+                <a:ea typeface="Microsoft YaHei"/>
               </a:rPr>
               <a:t>10 min</a:t>
             </a:r>
@@ -2499,6 +2581,7 @@
                 <a:effectLst/>
                 <a:uFillTx/>
                 <a:latin typeface="Arial"/>
+                <a:ea typeface="Microsoft YaHei"/>
               </a:rPr>
               <a:t>)</a:t>
             </a:r>
@@ -2525,6 +2608,7 @@
                 <a:effectLst/>
                 <a:uFillTx/>
                 <a:latin typeface="Arial"/>
+                <a:ea typeface="Microsoft YaHei"/>
               </a:rPr>
               <a:t>Compartiremos aprendizajes, retos superados y próximos pasos. Además, un espacio para preguntas abiertas y reflexiones finales. 🔑✨💻🤝</a:t>
             </a:r>
@@ -2538,6 +2622,11 @@
             </a:endParaRPr>
           </a:p>
           <a:p>
+            <a:pPr>
+              <a:lnSpc>
+                <a:spcPct val="100000"/>
+              </a:lnSpc>
+            </a:pPr>
             <a:endParaRPr b="0" lang="es-MX" sz="1800" strike="noStrike" u="none">
               <a:solidFill>
                 <a:srgbClr val="000000"/>
@@ -2595,7 +2684,7 @@
         <p:spPr>
           <a:xfrm>
             <a:off x="228600" y="1952280"/>
-            <a:ext cx="2724480" cy="2962080"/>
+            <a:ext cx="2724120" cy="2961720"/>
           </a:xfrm>
           <a:prstGeom prst="roundRect">
             <a:avLst>
@@ -2660,7 +2749,7 @@
         <p:spPr>
           <a:xfrm>
             <a:off x="3209400" y="1952280"/>
-            <a:ext cx="2724480" cy="2962080"/>
+            <a:ext cx="2724120" cy="2961720"/>
           </a:xfrm>
           <a:prstGeom prst="roundRect">
             <a:avLst>
@@ -2725,7 +2814,7 @@
         <p:spPr>
           <a:xfrm>
             <a:off x="6190560" y="1952280"/>
-            <a:ext cx="2724480" cy="2962080"/>
+            <a:ext cx="2724120" cy="2961720"/>
           </a:xfrm>
           <a:prstGeom prst="roundRect">
             <a:avLst>
@@ -2794,7 +2883,7 @@
         <p:spPr>
           <a:xfrm>
             <a:off x="228600" y="228600"/>
-            <a:ext cx="866520" cy="194040"/>
+            <a:ext cx="866160" cy="193680"/>
           </a:xfrm>
           <a:prstGeom prst="rect">
             <a:avLst/>
@@ -2818,7 +2907,7 @@
         <p:spPr>
           <a:xfrm>
             <a:off x="96840" y="424800"/>
-            <a:ext cx="8520120" cy="800640"/>
+            <a:ext cx="8519760" cy="801000"/>
           </a:xfrm>
           <a:prstGeom prst="rect">
             <a:avLst/>
@@ -2878,7 +2967,7 @@
         <p:spPr>
           <a:xfrm>
             <a:off x="424800" y="2191320"/>
-            <a:ext cx="474120" cy="760320"/>
+            <a:ext cx="473760" cy="759960"/>
           </a:xfrm>
           <a:prstGeom prst="rect">
             <a:avLst/>
@@ -2902,7 +2991,7 @@
         <p:spPr>
           <a:xfrm>
             <a:off x="3468960" y="2191320"/>
-            <a:ext cx="474120" cy="760320"/>
+            <a:ext cx="473760" cy="759960"/>
           </a:xfrm>
           <a:prstGeom prst="rect">
             <a:avLst/>
@@ -2926,7 +3015,7 @@
         <p:spPr>
           <a:xfrm>
             <a:off x="6407280" y="2191320"/>
-            <a:ext cx="474120" cy="760320"/>
+            <a:ext cx="473760" cy="759960"/>
           </a:xfrm>
           <a:prstGeom prst="rect">
             <a:avLst/>
@@ -2956,7 +3045,7 @@
     <p:bg>
       <p:bgPr>
         <a:solidFill>
-          <a:srgbClr val="65bd82"/>
+          <a:srgbClr val="f2f1ee"/>
         </a:solidFill>
       </p:bgPr>
     </p:bg>
@@ -2976,7 +3065,7 @@
       </p:grpSpPr>
       <p:pic>
         <p:nvPicPr>
-          <p:cNvPr id="30" name="Google Shape;240;p36" descr=""/>
+          <p:cNvPr id="30" name="Google Shape;140;p25" descr=""/>
           <p:cNvPicPr/>
           <p:nvPr/>
         </p:nvPicPr>
@@ -2987,7 +3076,7 @@
         <p:spPr>
           <a:xfrm>
             <a:off x="228600" y="228600"/>
-            <a:ext cx="866520" cy="194040"/>
+            <a:ext cx="866160" cy="193680"/>
           </a:xfrm>
           <a:prstGeom prst="rect">
             <a:avLst/>
@@ -3010,8 +3099,8 @@
         </p:nvSpPr>
         <p:spPr>
           <a:xfrm>
-            <a:off x="322920" y="817560"/>
-            <a:ext cx="6138000" cy="1846800"/>
+            <a:off x="96840" y="424800"/>
+            <a:ext cx="8519760" cy="800640"/>
           </a:xfrm>
           <a:prstGeom prst="rect">
             <a:avLst/>
@@ -3028,127 +3117,6 @@
           <a:p>
             <a:pPr indent="0">
               <a:lnSpc>
-                <a:spcPct val="90000"/>
-              </a:lnSpc>
-              <a:buNone/>
-              <a:tabLst>
-                <a:tab algn="l" pos="0"/>
-              </a:tabLst>
-            </a:pPr>
-            <a:r>
-              <a:rPr b="0" lang="es-ES" sz="6000" strike="noStrike" u="none">
-                <a:solidFill>
-                  <a:srgbClr val="1a1a1a"/>
-                </a:solidFill>
-                <a:effectLst/>
-                <a:uFillTx/>
-                <a:latin typeface="Inter ExtraBold"/>
-                <a:ea typeface="Inter ExtraBold"/>
-              </a:rPr>
-              <a:t>Midamos los ánimos</a:t>
-            </a:r>
-            <a:endParaRPr b="0" lang="es-MX" sz="6000" strike="noStrike" u="none">
-              <a:solidFill>
-                <a:srgbClr val="000000"/>
-              </a:solidFill>
-              <a:effectLst/>
-              <a:uFillTx/>
-              <a:latin typeface="Arial"/>
-            </a:endParaRPr>
-          </a:p>
-        </p:txBody>
-      </p:sp>
-    </p:spTree>
-  </p:cSld>
-  <mc:AlternateContent>
-    <mc:Choice Requires="p14">
-      <p:transition spd="slow" p14:dur="2000"/>
-    </mc:Choice>
-    <mc:Fallback>
-      <p:transition spd="slow"/>
-    </mc:Fallback>
-  </mc:AlternateContent>
-</p:sld>
-</file>
-
-<file path=ppt/slides/slide5.xml><?xml version="1.0" encoding="utf-8"?>
-<p:sld xmlns:a="http://schemas.openxmlformats.org/drawingml/2006/main" xmlns:p="http://schemas.openxmlformats.org/presentationml/2006/main" xmlns:r="http://schemas.openxmlformats.org/officeDocument/2006/relationships" xmlns:p14="http://schemas.microsoft.com/office/powerpoint/2010/main" xmlns:p15="http://schemas.microsoft.com/office/powerpoint/2012/main" xmlns:mc="http://schemas.openxmlformats.org/markup-compatibility/2006">
-  <p:cSld>
-    <p:bg>
-      <p:bgPr>
-        <a:solidFill>
-          <a:srgbClr val="f2f1ee"/>
-        </a:solidFill>
-      </p:bgPr>
-    </p:bg>
-    <p:spTree>
-      <p:nvGrpSpPr>
-        <p:cNvPr id="1" name=""/>
-        <p:cNvGrpSpPr/>
-        <p:nvPr/>
-      </p:nvGrpSpPr>
-      <p:grpSpPr>
-        <a:xfrm>
-          <a:off x="0" y="0"/>
-          <a:ext cx="0" cy="0"/>
-          <a:chOff x="0" y="0"/>
-          <a:chExt cx="0" cy="0"/>
-        </a:xfrm>
-      </p:grpSpPr>
-      <p:pic>
-        <p:nvPicPr>
-          <p:cNvPr id="32" name="Google Shape;140;p25" descr=""/>
-          <p:cNvPicPr/>
-          <p:nvPr/>
-        </p:nvPicPr>
-        <p:blipFill>
-          <a:blip r:embed="rId1"/>
-          <a:stretch/>
-        </p:blipFill>
-        <p:spPr>
-          <a:xfrm>
-            <a:off x="228600" y="228600"/>
-            <a:ext cx="866520" cy="194040"/>
-          </a:xfrm>
-          <a:prstGeom prst="rect">
-            <a:avLst/>
-          </a:prstGeom>
-          <a:noFill/>
-          <a:ln w="0">
-            <a:noFill/>
-          </a:ln>
-        </p:spPr>
-      </p:pic>
-      <p:sp>
-        <p:nvSpPr>
-          <p:cNvPr id="33" name="PlaceHolder 1"/>
-          <p:cNvSpPr>
-            <a:spLocks noGrp="1"/>
-          </p:cNvSpPr>
-          <p:nvPr>
-            <p:ph type="title"/>
-          </p:nvPr>
-        </p:nvSpPr>
-        <p:spPr>
-          <a:xfrm>
-            <a:off x="96840" y="424800"/>
-            <a:ext cx="8520120" cy="800280"/>
-          </a:xfrm>
-          <a:prstGeom prst="rect">
-            <a:avLst/>
-          </a:prstGeom>
-          <a:noFill/>
-          <a:ln w="0">
-            <a:noFill/>
-          </a:ln>
-        </p:spPr>
-        <p:txBody>
-          <a:bodyPr lIns="91440" rIns="91440" tIns="91440" bIns="91440" anchor="t">
-            <a:spAutoFit/>
-          </a:bodyPr>
-          <a:p>
-            <a:pPr indent="0">
-              <a:lnSpc>
                 <a:spcPct val="100000"/>
               </a:lnSpc>
               <a:buNone/>
@@ -3181,14 +3149,14 @@
       </p:sp>
       <p:sp>
         <p:nvSpPr>
-          <p:cNvPr id="34" name="Google Shape;142;p25"/>
+          <p:cNvPr id="32" name="Google Shape;142;p25"/>
           <p:cNvSpPr/>
           <p:nvPr/>
         </p:nvSpPr>
         <p:spPr>
           <a:xfrm>
             <a:off x="228600" y="1490760"/>
-            <a:ext cx="2779560" cy="3423960"/>
+            <a:ext cx="2779200" cy="3423600"/>
           </a:xfrm>
           <a:prstGeom prst="roundRect">
             <a:avLst>
@@ -3209,7 +3177,7 @@
           <a:fontRef idx="minor"/>
         </p:style>
         <p:txBody>
-          <a:bodyPr tIns="91440" bIns="0" anchor="t">
+          <a:bodyPr lIns="90000" rIns="90000" tIns="91440" bIns="0" anchor="t">
             <a:noAutofit/>
           </a:bodyPr>
           <a:p>
@@ -3306,14 +3274,14 @@
       </p:sp>
       <p:sp>
         <p:nvSpPr>
-          <p:cNvPr id="35" name="Google Shape;143;p25"/>
+          <p:cNvPr id="33" name="Google Shape;143;p25"/>
           <p:cNvSpPr/>
           <p:nvPr/>
         </p:nvSpPr>
         <p:spPr>
           <a:xfrm>
             <a:off x="3182040" y="1490760"/>
-            <a:ext cx="2779560" cy="3423960"/>
+            <a:ext cx="2779200" cy="3423600"/>
           </a:xfrm>
           <a:prstGeom prst="roundRect">
             <a:avLst>
@@ -3334,7 +3302,7 @@
           <a:fontRef idx="minor"/>
         </p:style>
         <p:txBody>
-          <a:bodyPr tIns="91440" bIns="0" anchor="t">
+          <a:bodyPr lIns="90000" rIns="90000" tIns="91440" bIns="0" anchor="t">
             <a:noAutofit/>
           </a:bodyPr>
           <a:p>
@@ -3479,14 +3447,14 @@
       </p:sp>
       <p:sp>
         <p:nvSpPr>
-          <p:cNvPr id="36" name="Google Shape;144;p25"/>
+          <p:cNvPr id="34" name="Google Shape;144;p25"/>
           <p:cNvSpPr/>
           <p:nvPr/>
         </p:nvSpPr>
         <p:spPr>
           <a:xfrm>
             <a:off x="6135480" y="1490760"/>
-            <a:ext cx="2779560" cy="3423960"/>
+            <a:ext cx="2779200" cy="3423600"/>
           </a:xfrm>
           <a:prstGeom prst="roundRect">
             <a:avLst>
@@ -3507,7 +3475,7 @@
           <a:fontRef idx="minor"/>
         </p:style>
         <p:txBody>
-          <a:bodyPr tIns="91440" bIns="0" anchor="t">
+          <a:bodyPr lIns="90000" rIns="90000" tIns="91440" bIns="0" anchor="t">
             <a:noAutofit/>
           </a:bodyPr>
           <a:p>
@@ -3615,7 +3583,7 @@
 </p:sld>
 </file>
 
-<file path=ppt/slides/slide6.xml><?xml version="1.0" encoding="utf-8"?>
+<file path=ppt/slides/slide5.xml><?xml version="1.0" encoding="utf-8"?>
 <p:sld xmlns:a="http://schemas.openxmlformats.org/drawingml/2006/main" xmlns:p="http://schemas.openxmlformats.org/presentationml/2006/main" xmlns:r="http://schemas.openxmlformats.org/officeDocument/2006/relationships" xmlns:p14="http://schemas.microsoft.com/office/powerpoint/2010/main" xmlns:p15="http://schemas.microsoft.com/office/powerpoint/2012/main" xmlns:mc="http://schemas.openxmlformats.org/markup-compatibility/2006">
   <p:cSld>
     <p:bg>
@@ -3641,7 +3609,7 @@
       </p:grpSpPr>
       <p:sp>
         <p:nvSpPr>
-          <p:cNvPr id="37" name="PlaceHolder 1"/>
+          <p:cNvPr id="35" name="PlaceHolder 1"/>
           <p:cNvSpPr>
             <a:spLocks noGrp="1"/>
           </p:cNvSpPr>
@@ -3652,7 +3620,7 @@
         <p:spPr>
           <a:xfrm>
             <a:off x="96840" y="2386440"/>
-            <a:ext cx="8520120" cy="2527920"/>
+            <a:ext cx="8519760" cy="2527560"/>
           </a:xfrm>
           <a:prstGeom prst="rect">
             <a:avLst/>
@@ -3690,7 +3658,7 @@
             </a:r>
             <a:endParaRPr b="0" lang="es-MX" sz="4800" strike="noStrike" u="none">
               <a:solidFill>
-                <a:srgbClr val="000000"/>
+                <a:srgbClr val="ffffff"/>
               </a:solidFill>
               <a:effectLst/>
               <a:uFillTx/>
@@ -3701,7 +3669,7 @@
       </p:sp>
       <p:pic>
         <p:nvPicPr>
-          <p:cNvPr id="38" name="Google Shape;235;p35" descr=""/>
+          <p:cNvPr id="36" name="Google Shape;235;p35" descr=""/>
           <p:cNvPicPr/>
           <p:nvPr/>
         </p:nvPicPr>
@@ -3712,7 +3680,7 @@
         <p:spPr>
           <a:xfrm>
             <a:off x="228600" y="228600"/>
-            <a:ext cx="868320" cy="191520"/>
+            <a:ext cx="867960" cy="191160"/>
           </a:xfrm>
           <a:prstGeom prst="rect">
             <a:avLst/>
@@ -3736,7 +3704,7 @@
 </p:sld>
 </file>
 
-<file path=ppt/slides/slide7.xml><?xml version="1.0" encoding="utf-8"?>
+<file path=ppt/slides/slide6.xml><?xml version="1.0" encoding="utf-8"?>
 <p:sld xmlns:a="http://schemas.openxmlformats.org/drawingml/2006/main" xmlns:p="http://schemas.openxmlformats.org/presentationml/2006/main" xmlns:r="http://schemas.openxmlformats.org/officeDocument/2006/relationships" xmlns:p14="http://schemas.microsoft.com/office/powerpoint/2010/main" xmlns:p15="http://schemas.microsoft.com/office/powerpoint/2012/main" xmlns:mc="http://schemas.openxmlformats.org/markup-compatibility/2006">
   <p:cSld>
     <p:bg>
@@ -3762,7 +3730,7 @@
       </p:grpSpPr>
       <p:pic>
         <p:nvPicPr>
-          <p:cNvPr id="39" name="Google Shape;240;p36" descr=""/>
+          <p:cNvPr id="37" name="Google Shape;240;p36" descr=""/>
           <p:cNvPicPr/>
           <p:nvPr/>
         </p:nvPicPr>
@@ -3773,7 +3741,7 @@
         <p:spPr>
           <a:xfrm>
             <a:off x="228600" y="228600"/>
-            <a:ext cx="866520" cy="194040"/>
+            <a:ext cx="866160" cy="193680"/>
           </a:xfrm>
           <a:prstGeom prst="rect">
             <a:avLst/>
@@ -3786,7 +3754,7 @@
       </p:pic>
       <p:sp>
         <p:nvSpPr>
-          <p:cNvPr id="40" name="PlaceHolder 1"/>
+          <p:cNvPr id="38" name="PlaceHolder 1"/>
           <p:cNvSpPr>
             <a:spLocks noGrp="1"/>
           </p:cNvSpPr>
@@ -3797,7 +3765,7 @@
         <p:spPr>
           <a:xfrm>
             <a:off x="322920" y="817560"/>
-            <a:ext cx="6138000" cy="2677680"/>
+            <a:ext cx="6137640" cy="2678040"/>
           </a:xfrm>
           <a:prstGeom prst="rect">
             <a:avLst/>
@@ -3857,7 +3825,7 @@
 </p:sld>
 </file>
 
-<file path=ppt/slides/slide8.xml><?xml version="1.0" encoding="utf-8"?>
+<file path=ppt/slides/slide7.xml><?xml version="1.0" encoding="utf-8"?>
 <p:sld xmlns:a="http://schemas.openxmlformats.org/drawingml/2006/main" xmlns:p="http://schemas.openxmlformats.org/presentationml/2006/main" xmlns:r="http://schemas.openxmlformats.org/officeDocument/2006/relationships" xmlns:p14="http://schemas.microsoft.com/office/powerpoint/2010/main" xmlns:p15="http://schemas.microsoft.com/office/powerpoint/2012/main" xmlns:mc="http://schemas.openxmlformats.org/markup-compatibility/2006">
   <p:cSld>
     <p:bg>
@@ -3883,7 +3851,7 @@
       </p:grpSpPr>
       <p:sp>
         <p:nvSpPr>
-          <p:cNvPr id="41" name="PlaceHolder 1"/>
+          <p:cNvPr id="39" name="PlaceHolder 1"/>
           <p:cNvSpPr>
             <a:spLocks noGrp="1"/>
           </p:cNvSpPr>
@@ -3894,7 +3862,7 @@
         <p:spPr>
           <a:xfrm>
             <a:off x="311760" y="1914120"/>
-            <a:ext cx="8520120" cy="923760"/>
+            <a:ext cx="8519760" cy="924120"/>
           </a:xfrm>
           <a:prstGeom prst="rect">
             <a:avLst/>
@@ -3943,7 +3911,7 @@
       </p:sp>
       <p:pic>
         <p:nvPicPr>
-          <p:cNvPr id="42" name="Google Shape;270;p39" descr=""/>
+          <p:cNvPr id="40" name="Google Shape;270;p39" descr=""/>
           <p:cNvPicPr/>
           <p:nvPr/>
         </p:nvPicPr>
@@ -3954,7 +3922,7 @@
         <p:spPr>
           <a:xfrm>
             <a:off x="3642120" y="2053080"/>
-            <a:ext cx="645120" cy="644760"/>
+            <a:ext cx="644760" cy="644400"/>
           </a:xfrm>
           <a:prstGeom prst="rect">
             <a:avLst/>
@@ -3967,7 +3935,7 @@
       </p:pic>
       <p:pic>
         <p:nvPicPr>
-          <p:cNvPr id="43" name="Google Shape;271;p39" descr=""/>
+          <p:cNvPr id="41" name="Google Shape;271;p39" descr=""/>
           <p:cNvPicPr/>
           <p:nvPr/>
         </p:nvPicPr>
@@ -3978,7 +3946,7 @@
         <p:spPr>
           <a:xfrm>
             <a:off x="4138560" y="228600"/>
-            <a:ext cx="866520" cy="194040"/>
+            <a:ext cx="866160" cy="193680"/>
           </a:xfrm>
           <a:prstGeom prst="rect">
             <a:avLst/>

</xml_diff>